<commit_message>
Few updates more pending
</commit_message>
<xml_diff>
--- a/Group-30/Presentation/Group30-CodeGen-Capstone-Presentation_Final.pptx
+++ b/Group-30/Presentation/Group30-CodeGen-Capstone-Presentation_Final.pptx
@@ -314,7 +314,7 @@
           <a:p>
             <a:fld id="{5BCAD085-E8A6-8845-BD4E-CB4CCA059FC4}" type="datetimeFigureOut">
               <a:rPr lang="en-US" smtClean="0"/>
-              <a:t>8/1/26</a:t>
+              <a:t>8/2/2026</a:t>
             </a:fld>
             <a:endParaRPr lang="en-US"/>
           </a:p>
@@ -482,7 +482,7 @@
           <a:p>
             <a:fld id="{5BCAD085-E8A6-8845-BD4E-CB4CCA059FC4}" type="datetimeFigureOut">
               <a:rPr lang="en-US" smtClean="0"/>
-              <a:t>8/1/26</a:t>
+              <a:t>8/2/2026</a:t>
             </a:fld>
             <a:endParaRPr lang="en-US"/>
           </a:p>
@@ -660,7 +660,7 @@
           <a:p>
             <a:fld id="{5BCAD085-E8A6-8845-BD4E-CB4CCA059FC4}" type="datetimeFigureOut">
               <a:rPr lang="en-US" smtClean="0"/>
-              <a:t>8/1/26</a:t>
+              <a:t>8/2/2026</a:t>
             </a:fld>
             <a:endParaRPr lang="en-US"/>
           </a:p>
@@ -828,7 +828,7 @@
           <a:p>
             <a:fld id="{5BCAD085-E8A6-8845-BD4E-CB4CCA059FC4}" type="datetimeFigureOut">
               <a:rPr lang="en-US" smtClean="0"/>
-              <a:t>8/1/26</a:t>
+              <a:t>8/2/2026</a:t>
             </a:fld>
             <a:endParaRPr lang="en-US"/>
           </a:p>
@@ -1073,7 +1073,7 @@
           <a:p>
             <a:fld id="{5BCAD085-E8A6-8845-BD4E-CB4CCA059FC4}" type="datetimeFigureOut">
               <a:rPr lang="en-US" smtClean="0"/>
-              <a:t>8/1/26</a:t>
+              <a:t>8/2/2026</a:t>
             </a:fld>
             <a:endParaRPr lang="en-US"/>
           </a:p>
@@ -1358,7 +1358,7 @@
           <a:p>
             <a:fld id="{5BCAD085-E8A6-8845-BD4E-CB4CCA059FC4}" type="datetimeFigureOut">
               <a:rPr lang="en-US" smtClean="0"/>
-              <a:t>8/1/26</a:t>
+              <a:t>8/2/2026</a:t>
             </a:fld>
             <a:endParaRPr lang="en-US"/>
           </a:p>
@@ -1777,7 +1777,7 @@
           <a:p>
             <a:fld id="{5BCAD085-E8A6-8845-BD4E-CB4CCA059FC4}" type="datetimeFigureOut">
               <a:rPr lang="en-US" smtClean="0"/>
-              <a:t>8/1/26</a:t>
+              <a:t>8/2/2026</a:t>
             </a:fld>
             <a:endParaRPr lang="en-US"/>
           </a:p>
@@ -1894,7 +1894,7 @@
           <a:p>
             <a:fld id="{5BCAD085-E8A6-8845-BD4E-CB4CCA059FC4}" type="datetimeFigureOut">
               <a:rPr lang="en-US" smtClean="0"/>
-              <a:t>8/1/26</a:t>
+              <a:t>8/2/2026</a:t>
             </a:fld>
             <a:endParaRPr lang="en-US"/>
           </a:p>
@@ -1989,7 +1989,7 @@
           <a:p>
             <a:fld id="{5BCAD085-E8A6-8845-BD4E-CB4CCA059FC4}" type="datetimeFigureOut">
               <a:rPr lang="en-US" smtClean="0"/>
-              <a:t>8/1/26</a:t>
+              <a:t>8/2/2026</a:t>
             </a:fld>
             <a:endParaRPr lang="en-US"/>
           </a:p>
@@ -2264,7 +2264,7 @@
           <a:p>
             <a:fld id="{5BCAD085-E8A6-8845-BD4E-CB4CCA059FC4}" type="datetimeFigureOut">
               <a:rPr lang="en-US" smtClean="0"/>
-              <a:t>8/1/26</a:t>
+              <a:t>8/2/2026</a:t>
             </a:fld>
             <a:endParaRPr lang="en-US"/>
           </a:p>
@@ -2516,7 +2516,7 @@
           <a:p>
             <a:fld id="{5BCAD085-E8A6-8845-BD4E-CB4CCA059FC4}" type="datetimeFigureOut">
               <a:rPr lang="en-US" smtClean="0"/>
-              <a:t>8/1/26</a:t>
+              <a:t>8/2/2026</a:t>
             </a:fld>
             <a:endParaRPr lang="en-US"/>
           </a:p>
@@ -2727,7 +2727,7 @@
           <a:p>
             <a:fld id="{5BCAD085-E8A6-8845-BD4E-CB4CCA059FC4}" type="datetimeFigureOut">
               <a:rPr lang="en-US" smtClean="0"/>
-              <a:t>8/1/26</a:t>
+              <a:t>8/2/2026</a:t>
             </a:fld>
             <a:endParaRPr lang="en-US"/>
           </a:p>
@@ -3324,7 +3324,7 @@
                 </a:solidFill>
                 <a:latin typeface="Calibri"/>
               </a:rPr>
-              <a:t>Natural Language → Python </a:t>
+              <a:t>Natural Language</a:t>
             </a:r>
             <a:r>
               <a:rPr lang="en-US" sz="1900" b="0" i="1" dirty="0">
@@ -3333,7 +3333,7 @@
                 </a:solidFill>
                 <a:latin typeface="Calibri"/>
               </a:rPr>
-              <a:t> or C++, Python </a:t>
+              <a:t> → </a:t>
             </a:r>
             <a:r>
               <a:rPr sz="1900" b="0" i="1" dirty="0">
@@ -3342,7 +3342,16 @@
                 </a:solidFill>
                 <a:latin typeface="Calibri"/>
               </a:rPr>
-              <a:t>→ C++, with Voice-Enabled Interaction</a:t>
+              <a:t>Python </a:t>
+            </a:r>
+            <a:r>
+              <a:rPr lang="en-US" sz="1900" b="0" i="1" dirty="0">
+                <a:solidFill>
+                  <a:srgbClr val="C7D9E2"/>
+                </a:solidFill>
+                <a:latin typeface="Calibri"/>
+              </a:rPr>
+              <a:t> or C++ and C++ -&gt; Python with Voice-Enabled Interaction</a:t>
             </a:r>
           </a:p>
         </p:txBody>
@@ -3762,7 +3771,7 @@
         <p:spPr>
           <a:xfrm>
             <a:off x="868680" y="6355080"/>
-            <a:ext cx="7315200" cy="274320"/>
+            <a:ext cx="7315200" cy="169277"/>
           </a:xfrm>
           <a:prstGeom prst="rect">
             <a:avLst/>
@@ -3781,9 +3790,9 @@
               </a:lnSpc>
             </a:pPr>
             <a:r>
-              <a:rPr sz="1100" b="0" i="1">
-                <a:solidFill>
-                  <a:srgbClr val="555F6E"/>
+              <a:rPr sz="1100" b="0" i="1" dirty="0">
+                <a:solidFill>
+                  <a:schemeClr val="bg1"/>
                 </a:solidFill>
                 <a:latin typeface="Calibri"/>
               </a:rPr>
@@ -4596,11 +4605,17 @@
           <p:cNvGraphicFramePr>
             <a:graphicFrameLocks noGrp="1"/>
           </p:cNvGraphicFramePr>
-          <p:nvPr/>
+          <p:nvPr>
+            <p:extLst>
+              <p:ext uri="{D42A27DB-BD31-4B8C-83A1-F6EECF244321}">
+                <p14:modId xmlns:p14="http://schemas.microsoft.com/office/powerpoint/2010/main" val="1116290428"/>
+              </p:ext>
+            </p:extLst>
+          </p:nvPr>
         </p:nvGraphicFramePr>
         <p:xfrm>
           <a:off x="502920" y="1691640"/>
-          <a:ext cx="11201400" cy="4526267"/>
+          <a:ext cx="11201400" cy="4554656"/>
         </p:xfrm>
         <a:graphic>
           <a:graphicData uri="http://schemas.openxmlformats.org/drawingml/2006/table">
@@ -4715,7 +4730,7 @@
                     <a:p>
                       <a:pPr algn="l"/>
                       <a:r>
-                        <a:rPr sz="1100" b="1" i="1">
+                        <a:rPr sz="1100" b="1" i="1" dirty="0">
                           <a:solidFill>
                             <a:srgbClr val="555F6E"/>
                           </a:solidFill>
@@ -4723,6 +4738,112 @@
                         </a:rPr>
                         <a:t>codegen-350m</a:t>
                       </a:r>
+                      <a:r>
+                        <a:rPr lang="en-US" sz="1600" b="1" i="1" baseline="30000" dirty="0">
+                          <a:solidFill>
+                            <a:srgbClr val="FF0000"/>
+                          </a:solidFill>
+                          <a:latin typeface="Calibri"/>
+                        </a:rPr>
+                        <a:t>*</a:t>
+                      </a:r>
+                      <a:endParaRPr sz="1100" b="1" i="1" dirty="0">
+                        <a:solidFill>
+                          <a:srgbClr val="FF0000"/>
+                        </a:solidFill>
+                        <a:latin typeface="Calibri"/>
+                      </a:endParaRPr>
+                    </a:p>
+                  </a:txBody>
+                  <a:tcPr marL="76200" marR="76200" marT="25400" marB="25400" anchor="ctr">
+                    <a:solidFill>
+                      <a:srgbClr val="F6F3EC"/>
+                    </a:solidFill>
+                  </a:tcPr>
+                </a:tc>
+                <a:tc>
+                  <a:txBody>
+                    <a:bodyPr/>
+                    <a:lstStyle/>
+                    <a:p>
+                      <a:pPr algn="ctr"/>
+                      <a:r>
+                        <a:rPr sz="1100" b="0" i="1" dirty="0">
+                          <a:solidFill>
+                            <a:srgbClr val="9AA3AE"/>
+                          </a:solidFill>
+                          <a:latin typeface="Calibri"/>
+                        </a:rPr>
+                        <a:t>NA</a:t>
+                      </a:r>
+                    </a:p>
+                  </a:txBody>
+                  <a:tcPr marL="76200" marR="76200" marT="25400" marB="25400" anchor="ctr">
+                    <a:solidFill>
+                      <a:srgbClr val="F6F3EC"/>
+                    </a:solidFill>
+                  </a:tcPr>
+                </a:tc>
+                <a:tc>
+                  <a:txBody>
+                    <a:bodyPr/>
+                    <a:lstStyle/>
+                    <a:p>
+                      <a:pPr algn="ctr"/>
+                      <a:r>
+                        <a:rPr sz="1100" b="0" i="1" dirty="0">
+                          <a:solidFill>
+                            <a:srgbClr val="9AA3AE"/>
+                          </a:solidFill>
+                          <a:latin typeface="Calibri"/>
+                        </a:rPr>
+                        <a:t>NA</a:t>
+                      </a:r>
+                    </a:p>
+                  </a:txBody>
+                  <a:tcPr marL="76200" marR="76200" marT="25400" marB="25400" anchor="ctr">
+                    <a:solidFill>
+                      <a:srgbClr val="F6F3EC"/>
+                    </a:solidFill>
+                  </a:tcPr>
+                </a:tc>
+                <a:extLst>
+                  <a:ext uri="{0D108BD9-81ED-4DB2-BD59-A6C34878D82A}">
+                    <a16:rowId xmlns:a16="http://schemas.microsoft.com/office/drawing/2014/main" val="3365092156"/>
+                  </a:ext>
+                </a:extLst>
+              </a:tr>
+              <a:tr h="266251">
+                <a:tc>
+                  <a:txBody>
+                    <a:bodyPr/>
+                    <a:lstStyle/>
+                    <a:p>
+                      <a:pPr algn="l"/>
+                      <a:r>
+                        <a:rPr sz="1100" b="1" i="1" dirty="0">
+                          <a:solidFill>
+                            <a:srgbClr val="555F6E"/>
+                          </a:solidFill>
+                          <a:latin typeface="Calibri"/>
+                        </a:rPr>
+                        <a:t>Qwen-0.5B</a:t>
+                      </a:r>
+                      <a:r>
+                        <a:rPr lang="en-US" sz="1100" b="1" i="1" dirty="0">
+                          <a:solidFill>
+                            <a:srgbClr val="FF0000"/>
+                          </a:solidFill>
+                          <a:latin typeface="+mn-lt"/>
+                        </a:rPr>
+                        <a:t>*</a:t>
+                      </a:r>
+                      <a:endParaRPr sz="1100" b="1" i="1" dirty="0">
+                        <a:solidFill>
+                          <a:srgbClr val="FF0000"/>
+                        </a:solidFill>
+                        <a:latin typeface="Calibri"/>
+                      </a:endParaRPr>
                     </a:p>
                   </a:txBody>
                   <a:tcPr marL="76200" marR="76200" marT="25400" marB="25400" anchor="ctr">
@@ -4761,7 +4882,7 @@
                     <a:p>
                       <a:pPr algn="ctr"/>
                       <a:r>
-                        <a:rPr sz="1100" b="0" i="1">
+                        <a:rPr sz="1100" b="0" i="1" dirty="0">
                           <a:solidFill>
                             <a:srgbClr val="9AA3AE"/>
                           </a:solidFill>
@@ -4791,7 +4912,7 @@
                     <a:p>
                       <a:pPr algn="l"/>
                       <a:r>
-                        <a:rPr sz="1200" b="1" i="0">
+                        <a:rPr sz="1200" b="1" i="0" dirty="0">
                           <a:solidFill>
                             <a:srgbClr val="FFFFFF"/>
                           </a:solidFill>
@@ -4917,7 +5038,7 @@
                     <a:p>
                       <a:pPr algn="l"/>
                       <a:r>
-                        <a:rPr sz="1100" b="0" i="0">
+                        <a:rPr sz="1100" b="0" i="0" dirty="0">
                           <a:solidFill>
                             <a:srgbClr val="1A1F2B"/>
                           </a:solidFill>
@@ -5347,7 +5468,7 @@
                     <a:p>
                       <a:pPr algn="l"/>
                       <a:r>
-                        <a:rPr sz="1100" b="0" i="0">
+                        <a:rPr sz="1100" b="0" i="0" dirty="0">
                           <a:solidFill>
                             <a:srgbClr val="1A1F2B"/>
                           </a:solidFill>
@@ -5773,7 +5894,7 @@
                     <a:p>
                       <a:pPr algn="ctr"/>
                       <a:r>
-                        <a:rPr sz="1100" b="1" i="0">
+                        <a:rPr sz="1100" b="1" i="0" dirty="0">
                           <a:solidFill>
                             <a:srgbClr val="1A1F2B"/>
                           </a:solidFill>
@@ -5795,82 +5916,6 @@
                   </a:ext>
                 </a:extLst>
               </a:tr>
-              <a:tr h="266251">
-                <a:tc>
-                  <a:txBody>
-                    <a:bodyPr/>
-                    <a:lstStyle/>
-                    <a:p>
-                      <a:pPr algn="l"/>
-                      <a:r>
-                        <a:rPr sz="1100" b="1" i="1">
-                          <a:solidFill>
-                            <a:srgbClr val="555F6E"/>
-                          </a:solidFill>
-                          <a:latin typeface="Calibri"/>
-                        </a:rPr>
-                        <a:t>Qwen-0.5B</a:t>
-                      </a:r>
-                    </a:p>
-                  </a:txBody>
-                  <a:tcPr marL="76200" marR="76200" marT="25400" marB="25400" anchor="ctr">
-                    <a:solidFill>
-                      <a:srgbClr val="F6F3EC"/>
-                    </a:solidFill>
-                  </a:tcPr>
-                </a:tc>
-                <a:tc>
-                  <a:txBody>
-                    <a:bodyPr/>
-                    <a:lstStyle/>
-                    <a:p>
-                      <a:pPr algn="ctr"/>
-                      <a:r>
-                        <a:rPr sz="1100" b="0" i="1">
-                          <a:solidFill>
-                            <a:srgbClr val="9AA3AE"/>
-                          </a:solidFill>
-                          <a:latin typeface="Calibri"/>
-                        </a:rPr>
-                        <a:t>NA</a:t>
-                      </a:r>
-                    </a:p>
-                  </a:txBody>
-                  <a:tcPr marL="76200" marR="76200" marT="25400" marB="25400" anchor="ctr">
-                    <a:solidFill>
-                      <a:srgbClr val="F6F3EC"/>
-                    </a:solidFill>
-                  </a:tcPr>
-                </a:tc>
-                <a:tc>
-                  <a:txBody>
-                    <a:bodyPr/>
-                    <a:lstStyle/>
-                    <a:p>
-                      <a:pPr algn="ctr"/>
-                      <a:r>
-                        <a:rPr sz="1100" b="0" i="1">
-                          <a:solidFill>
-                            <a:srgbClr val="9AA3AE"/>
-                          </a:solidFill>
-                          <a:latin typeface="Calibri"/>
-                        </a:rPr>
-                        <a:t>NA</a:t>
-                      </a:r>
-                    </a:p>
-                  </a:txBody>
-                  <a:tcPr marL="76200" marR="76200" marT="25400" marB="25400" anchor="ctr">
-                    <a:solidFill>
-                      <a:srgbClr val="F6F3EC"/>
-                    </a:solidFill>
-                  </a:tcPr>
-                </a:tc>
-                <a:extLst>
-                  <a:ext uri="{0D108BD9-81ED-4DB2-BD59-A6C34878D82A}">
-                    <a16:rowId xmlns:a16="http://schemas.microsoft.com/office/drawing/2014/main" val="10016"/>
-                  </a:ext>
-                </a:extLst>
-              </a:tr>
             </a:tbl>
           </a:graphicData>
         </a:graphic>
@@ -5884,7 +5929,7 @@
         <p:spPr>
           <a:xfrm>
             <a:off x="502920" y="6272784"/>
-            <a:ext cx="11155680" cy="128016"/>
+            <a:ext cx="11155680" cy="146194"/>
           </a:xfrm>
           <a:prstGeom prst="rect">
             <a:avLst/>
@@ -5897,13 +5942,16 @@
           </a:bodyPr>
           <a:lstStyle/>
           <a:p>
-            <a:pPr algn="l">
-              <a:lnSpc>
-                <a:spcPct val="100000"/>
-              </a:lnSpc>
-            </a:pPr>
-            <a:r>
-              <a:rPr sz="950" b="0" i="1">
+            <a:r>
+              <a:rPr lang="en-US" sz="1000" b="1" i="1" baseline="30000" dirty="0">
+                <a:solidFill>
+                  <a:srgbClr val="FF0000"/>
+                </a:solidFill>
+              </a:rPr>
+              <a:t>*</a:t>
+            </a:r>
+            <a:r>
+              <a:rPr sz="950" b="0" i="1" dirty="0">
                 <a:solidFill>
                   <a:srgbClr val="555F6E"/>
                 </a:solidFill>
@@ -6548,7 +6596,7 @@
         <p:spPr>
           <a:xfrm>
             <a:off x="868680" y="5120640"/>
-            <a:ext cx="8229600" cy="365760"/>
+            <a:ext cx="8229600" cy="184666"/>
           </a:xfrm>
           <a:prstGeom prst="rect">
             <a:avLst/>
@@ -6569,7 +6617,7 @@
             <a:r>
               <a:rPr sz="1200" b="0" i="1" dirty="0" err="1">
                 <a:solidFill>
-                  <a:srgbClr val="555F6E"/>
+                  <a:schemeClr val="bg1"/>
                 </a:solidFill>
                 <a:latin typeface="Calibri"/>
               </a:rPr>
@@ -6578,7 +6626,7 @@
             <a:r>
               <a:rPr sz="1200" b="0" i="1" dirty="0">
                 <a:solidFill>
-                  <a:srgbClr val="555F6E"/>
+                  <a:schemeClr val="bg1"/>
                 </a:solidFill>
                 <a:latin typeface="Calibri"/>
               </a:rPr>
@@ -6948,7 +6996,7 @@
                 </a:solidFill>
                 <a:latin typeface="Calibri"/>
               </a:rPr>
-              <a:t>and Python to C++ translation</a:t>
+              <a:t>and C++ to Python translation</a:t>
             </a:r>
             <a:r>
               <a:rPr sz="1350" b="0" i="0" dirty="0">
@@ -6957,8 +7005,32 @@
                 </a:solidFill>
                 <a:latin typeface="Calibri"/>
               </a:rPr>
-              <a:t>— demonstrating a path to extend code-generation support to languages an LLM was not originally trained on.</a:t>
-            </a:r>
+              <a:t>— demonstrating a path to extend code-generation support to languages </a:t>
+            </a:r>
+            <a:r>
+              <a:rPr lang="en-US" sz="1350" b="0" i="0" dirty="0">
+                <a:solidFill>
+                  <a:srgbClr val="1A1F2B"/>
+                </a:solidFill>
+                <a:latin typeface="Calibri"/>
+              </a:rPr>
+              <a:t>or tasks </a:t>
+            </a:r>
+            <a:r>
+              <a:rPr sz="1350" b="0" i="0" dirty="0">
+                <a:solidFill>
+                  <a:srgbClr val="1A1F2B"/>
+                </a:solidFill>
+                <a:latin typeface="Calibri"/>
+              </a:rPr>
+              <a:t>an LLM was not originally trained on.</a:t>
+            </a:r>
+            <a:endParaRPr lang="en-US" sz="1350" b="0" i="0" dirty="0">
+              <a:solidFill>
+                <a:srgbClr val="1A1F2B"/>
+              </a:solidFill>
+              <a:latin typeface="Calibri"/>
+            </a:endParaRPr>
           </a:p>
         </p:txBody>
       </p:sp>
@@ -7229,7 +7301,7 @@
         <p:spPr>
           <a:xfrm>
             <a:off x="777240" y="3337560"/>
-            <a:ext cx="4892040" cy="2345129"/>
+            <a:ext cx="4892040" cy="2663806"/>
           </a:xfrm>
           <a:prstGeom prst="rect">
             <a:avLst/>
@@ -7241,6 +7313,96 @@
             <a:spAutoFit/>
           </a:bodyPr>
           <a:lstStyle/>
+          <a:p>
+            <a:pPr>
+              <a:lnSpc>
+                <a:spcPct val="108000"/>
+              </a:lnSpc>
+              <a:spcAft>
+                <a:spcPts val="800"/>
+              </a:spcAft>
+            </a:pPr>
+            <a:r>
+              <a:rPr sz="1300" b="1" dirty="0">
+                <a:solidFill>
+                  <a:srgbClr val="1F7A8C"/>
+                </a:solidFill>
+                <a:latin typeface="Calibri"/>
+              </a:rPr>
+              <a:t>▪  </a:t>
+            </a:r>
+            <a:r>
+              <a:rPr sz="1300" b="0" i="0" dirty="0">
+                <a:solidFill>
+                  <a:srgbClr val="1A1F2B"/>
+                </a:solidFill>
+                <a:latin typeface="Calibri"/>
+              </a:rPr>
+              <a:t>Baseline accuracy for NL → Python</a:t>
+            </a:r>
+            <a:r>
+              <a:rPr lang="en-US" sz="1300" b="0" i="0" dirty="0">
+                <a:solidFill>
+                  <a:srgbClr val="1A1F2B"/>
+                </a:solidFill>
+                <a:latin typeface="Calibri"/>
+              </a:rPr>
+              <a:t>/C++</a:t>
+            </a:r>
+            <a:r>
+              <a:rPr sz="1300" b="0" i="0" dirty="0">
+                <a:solidFill>
+                  <a:srgbClr val="1A1F2B"/>
+                </a:solidFill>
+                <a:latin typeface="Calibri"/>
+              </a:rPr>
+              <a:t> and </a:t>
+            </a:r>
+            <a:r>
+              <a:rPr lang="en-US" sz="1300" b="0" i="0" dirty="0">
+                <a:solidFill>
+                  <a:srgbClr val="1A1F2B"/>
+                </a:solidFill>
+                <a:latin typeface="Calibri"/>
+              </a:rPr>
+              <a:t>C++ </a:t>
+            </a:r>
+            <a:r>
+              <a:rPr sz="1300" b="0" i="0" dirty="0">
+                <a:solidFill>
+                  <a:srgbClr val="1A1F2B"/>
+                </a:solidFill>
+                <a:latin typeface="Calibri"/>
+              </a:rPr>
+              <a:t>→ </a:t>
+            </a:r>
+            <a:r>
+              <a:rPr lang="en-US" sz="1300" dirty="0">
+                <a:solidFill>
+                  <a:srgbClr val="1A1F2B"/>
+                </a:solidFill>
+              </a:rPr>
+              <a:t>Python </a:t>
+            </a:r>
+            <a:r>
+              <a:rPr lang="en-US" sz="1300" b="0" i="0" dirty="0">
+                <a:solidFill>
+                  <a:srgbClr val="1A1F2B"/>
+                </a:solidFill>
+                <a:latin typeface="Calibri"/>
+              </a:rPr>
+              <a:t>translation</a:t>
+            </a:r>
+            <a:r>
+              <a:rPr sz="1300" b="0" i="0" dirty="0">
+                <a:solidFill>
+                  <a:srgbClr val="1A1F2B"/>
+                </a:solidFill>
+                <a:latin typeface="Calibri"/>
+              </a:rPr>
+              <a:t> using Qwen2.5-Coder-7B-Instruct</a:t>
+            </a:r>
+          </a:p>
           <a:p>
             <a:pPr marL="0" indent="0" algn="l">
               <a:lnSpc>
@@ -7260,13 +7422,22 @@
               <a:t>▪  </a:t>
             </a:r>
             <a:r>
+              <a:rPr sz="1300" b="0" i="0" dirty="0" err="1">
+                <a:solidFill>
+                  <a:srgbClr val="1A1F2B"/>
+                </a:solidFill>
+                <a:latin typeface="Calibri"/>
+              </a:rPr>
+              <a:t>LoRA</a:t>
+            </a:r>
+            <a:r>
               <a:rPr sz="1300" b="0" i="0" dirty="0">
                 <a:solidFill>
                   <a:srgbClr val="1A1F2B"/>
                 </a:solidFill>
                 <a:latin typeface="Calibri"/>
               </a:rPr>
-              <a:t>Baseline accuracy for NL → Python</a:t>
+              <a:t> fine-tuning in two phases: NL → PL1 (Python</a:t>
             </a:r>
             <a:r>
               <a:rPr lang="en-US" sz="1300" b="0" i="0" dirty="0">
@@ -7284,8 +7455,126 @@
                 </a:solidFill>
                 <a:latin typeface="Calibri"/>
               </a:rPr>
-              <a:t> and Python → C++ generation using Qwen2.5-Coder-7B-Instruct</a:t>
-            </a:r>
+              <a:t>) and PL1 → PL2 (</a:t>
+            </a:r>
+            <a:r>
+              <a:rPr lang="en-US" sz="1300" b="0" i="0" dirty="0">
+                <a:solidFill>
+                  <a:srgbClr val="1A1F2B"/>
+                </a:solidFill>
+                <a:latin typeface="Calibri"/>
+              </a:rPr>
+              <a:t>C++ -&gt; Python)</a:t>
+            </a:r>
+            <a:endParaRPr lang="en-US" sz="1300" b="0" i="0" dirty="0">
+              <a:solidFill>
+                <a:srgbClr val="1A1F2B"/>
+              </a:solidFill>
+              <a:highlight>
+                <a:srgbClr val="FFFF00"/>
+              </a:highlight>
+              <a:latin typeface="Calibri"/>
+            </a:endParaRPr>
+          </a:p>
+          <a:p>
+            <a:pPr>
+              <a:lnSpc>
+                <a:spcPct val="108000"/>
+              </a:lnSpc>
+              <a:spcAft>
+                <a:spcPts val="800"/>
+              </a:spcAft>
+            </a:pPr>
+            <a:r>
+              <a:rPr lang="en-US" sz="1300" b="1" dirty="0">
+                <a:solidFill>
+                  <a:srgbClr val="1F7A8C"/>
+                </a:solidFill>
+              </a:rPr>
+              <a:t>▪  </a:t>
+            </a:r>
+            <a:r>
+              <a:rPr lang="en-US" sz="1300" dirty="0">
+                <a:solidFill>
+                  <a:srgbClr val="1A1F2B"/>
+                </a:solidFill>
+              </a:rPr>
+              <a:t>PL1-&gt; PL2. PL1-&gt; Documentation-&gt; PL2 Code -&gt; Translate to PL1 -&gt; Compare with ground truth PL1</a:t>
+            </a:r>
+          </a:p>
+          <a:p>
+            <a:pPr marL="571500" lvl="1" indent="-114300">
+              <a:lnSpc>
+                <a:spcPct val="108000"/>
+              </a:lnSpc>
+              <a:spcAft>
+                <a:spcPts val="800"/>
+              </a:spcAft>
+            </a:pPr>
+            <a:r>
+              <a:rPr sz="1300" b="1" dirty="0">
+                <a:solidFill>
+                  <a:srgbClr val="1F7A8C"/>
+                </a:solidFill>
+                <a:latin typeface="Calibri"/>
+              </a:rPr>
+              <a:t>▪ </a:t>
+            </a:r>
+            <a:r>
+              <a:rPr lang="en-US" sz="1300" dirty="0">
+                <a:solidFill>
+                  <a:srgbClr val="1A1F2B"/>
+                </a:solidFill>
+              </a:rPr>
+              <a:t>PL1-&gt; Documentation- </a:t>
+            </a:r>
+            <a:r>
+              <a:rPr sz="1300" b="0" i="0" dirty="0">
+                <a:solidFill>
+                  <a:srgbClr val="1A1F2B"/>
+                </a:solidFill>
+                <a:latin typeface="Calibri"/>
+              </a:rPr>
+              <a:t>Best documentation selected from 3 generation iterations, scored per record</a:t>
+            </a:r>
+            <a:endParaRPr lang="en-US" sz="1300" b="0" i="0" dirty="0">
+              <a:solidFill>
+                <a:srgbClr val="1A1F2B"/>
+              </a:solidFill>
+              <a:latin typeface="Calibri"/>
+            </a:endParaRPr>
+          </a:p>
+          <a:p>
+            <a:pPr lvl="1">
+              <a:lnSpc>
+                <a:spcPct val="108000"/>
+              </a:lnSpc>
+              <a:spcAft>
+                <a:spcPts val="800"/>
+              </a:spcAft>
+            </a:pPr>
+            <a:r>
+              <a:rPr lang="en-US" sz="1300" b="1" dirty="0">
+                <a:solidFill>
+                  <a:srgbClr val="1F7A8C"/>
+                </a:solidFill>
+              </a:rPr>
+              <a:t>▪ </a:t>
+            </a:r>
+            <a:r>
+              <a:rPr lang="en-US" sz="1300" dirty="0">
+                <a:solidFill>
+                  <a:srgbClr val="1A1F2B"/>
+                </a:solidFill>
+              </a:rPr>
+              <a:t>Documentation-&gt; PL2 Code: LLM-as-judge</a:t>
+            </a:r>
+            <a:endParaRPr sz="1300" b="0" i="0" dirty="0">
+              <a:solidFill>
+                <a:srgbClr val="1A1F2B"/>
+              </a:solidFill>
+              <a:latin typeface="Calibri"/>
+            </a:endParaRPr>
           </a:p>
           <a:p>
             <a:pPr marL="0" indent="0" algn="l">
@@ -7306,92 +7595,53 @@
               <a:t>▪  </a:t>
             </a:r>
             <a:r>
+              <a:rPr sz="1300" b="0" i="0" dirty="0">
+                <a:solidFill>
+                  <a:srgbClr val="1A1F2B"/>
+                </a:solidFill>
+                <a:latin typeface="Calibri"/>
+              </a:rPr>
+              <a:t>Evaluation via AST similarity + </a:t>
+            </a:r>
+            <a:r>
               <a:rPr sz="1300" b="0" i="0" dirty="0" err="1">
                 <a:solidFill>
                   <a:srgbClr val="1A1F2B"/>
                 </a:solidFill>
                 <a:latin typeface="Calibri"/>
               </a:rPr>
-              <a:t>LoRA</a:t>
-            </a:r>
-            <a:r>
-              <a:rPr sz="1300" b="0" i="0" dirty="0">
-                <a:solidFill>
-                  <a:srgbClr val="1A1F2B"/>
-                </a:solidFill>
-                <a:latin typeface="Calibri"/>
-              </a:rPr>
-              <a:t> fine-tuning in two phases: NL → PL1 (Python</a:t>
-            </a:r>
-            <a:r>
-              <a:rPr lang="en-US" sz="1300" b="0" i="0" dirty="0">
-                <a:solidFill>
-                  <a:srgbClr val="1A1F2B"/>
-                </a:solidFill>
-                <a:latin typeface="Calibri"/>
-              </a:rPr>
-              <a:t>/C++</a:t>
-            </a:r>
-            <a:r>
-              <a:rPr sz="1300" b="0" i="0" dirty="0">
-                <a:solidFill>
-                  <a:srgbClr val="1A1F2B"/>
-                </a:solidFill>
-                <a:latin typeface="Calibri"/>
-              </a:rPr>
-              <a:t>) and PL1 → PL2 (Python  </a:t>
-            </a:r>
-            <a:r>
-              <a:rPr lang="en-US" sz="1300" b="0" i="0" dirty="0">
-                <a:solidFill>
-                  <a:srgbClr val="1A1F2B"/>
-                </a:solidFill>
-                <a:latin typeface="Calibri"/>
-              </a:rPr>
-              <a:t>-&gt; </a:t>
-            </a:r>
-            <a:r>
-              <a:rPr sz="1300" b="0" i="0" dirty="0">
-                <a:solidFill>
-                  <a:srgbClr val="1A1F2B"/>
-                </a:solidFill>
-                <a:latin typeface="Calibri"/>
-              </a:rPr>
-              <a:t>C++)</a:t>
-            </a:r>
-            <a:endParaRPr lang="en-US" sz="1300" b="0" i="0" dirty="0">
+              <a:t>GraphCodeBERTScore</a:t>
+            </a:r>
+            <a:endParaRPr sz="1300" b="0" i="0" dirty="0">
               <a:solidFill>
                 <a:srgbClr val="1A1F2B"/>
               </a:solidFill>
               <a:latin typeface="Calibri"/>
             </a:endParaRPr>
           </a:p>
-          <a:p>
-            <a:pPr>
-              <a:lnSpc>
-                <a:spcPct val="108000"/>
-              </a:lnSpc>
-              <a:spcAft>
-                <a:spcPts val="800"/>
-              </a:spcAft>
-            </a:pPr>
-            <a:r>
-              <a:rPr lang="en-US" sz="1300" b="1" dirty="0">
-                <a:solidFill>
-                  <a:srgbClr val="1F7A8C"/>
-                </a:solidFill>
-              </a:rPr>
-              <a:t>▪  </a:t>
-            </a:r>
-            <a:r>
-              <a:rPr lang="en-US" sz="1300" dirty="0">
-                <a:solidFill>
-                  <a:srgbClr val="1A1F2B"/>
-                </a:solidFill>
-              </a:rPr>
-              <a:t>PL1-&gt; PL2. PL1-&gt; Documentation-&gt; PL2 Code -&gt; Translate to PL1 -&gt; Compare with ground truth PL1</a:t>
-            </a:r>
-          </a:p>
+        </p:txBody>
+      </p:sp>
+      <p:sp>
+        <p:nvSpPr>
+          <p:cNvPr id="17" name="TextBox 16"/>
+          <p:cNvSpPr txBox="1"/>
+          <p:nvPr/>
+        </p:nvSpPr>
+        <p:spPr>
+          <a:xfrm>
+            <a:off x="6537960" y="3337560"/>
+            <a:ext cx="4892040" cy="1594283"/>
+          </a:xfrm>
+          <a:prstGeom prst="rect">
+            <a:avLst/>
+          </a:prstGeom>
+          <a:noFill/>
+        </p:spPr>
+        <p:txBody>
+          <a:bodyPr wrap="square" lIns="0" tIns="0" rIns="0" bIns="0" anchor="t">
+            <a:spAutoFit/>
+          </a:bodyPr>
+          <a:lstStyle/>
           <a:p>
             <a:pPr marL="0" indent="0" algn="l">
               <a:lnSpc>
@@ -7417,7 +7667,7 @@
                 </a:solidFill>
                 <a:latin typeface="Calibri"/>
               </a:rPr>
-              <a:t>Best documentation selected from 3 generation iterations, scored per record</a:t>
+              <a:t>ASR (Whisper) — speak a natural-language prompt → transcribed → code generated (NL → PL)</a:t>
             </a:r>
           </a:p>
           <a:p>
@@ -7445,16 +7695,16 @@
                 </a:solidFill>
                 <a:latin typeface="Calibri"/>
               </a:rPr>
-              <a:t>Evaluation via AST similarity + </a:t>
-            </a:r>
-            <a:r>
-              <a:rPr sz="1300" b="0" i="0" dirty="0" err="1">
+              <a:t>Text interface for PL → PL — paste </a:t>
+            </a:r>
+            <a:r>
+              <a:rPr lang="en-US" sz="1300" b="0" i="0" dirty="0">
                 <a:solidFill>
                   <a:srgbClr val="1A1F2B"/>
                 </a:solidFill>
                 <a:latin typeface="Calibri"/>
               </a:rPr>
-              <a:t>GraphCodeBERTScore</a:t>
+              <a:t>C++</a:t>
             </a:r>
             <a:r>
               <a:rPr sz="1300" b="0" i="0" dirty="0">
@@ -7463,32 +7713,24 @@
                 </a:solidFill>
                 <a:latin typeface="Calibri"/>
               </a:rPr>
-              <a:t> + LLM-as-judge</a:t>
-            </a:r>
-          </a:p>
-        </p:txBody>
-      </p:sp>
-      <p:sp>
-        <p:nvSpPr>
-          <p:cNvPr id="17" name="TextBox 16"/>
-          <p:cNvSpPr txBox="1"/>
-          <p:nvPr/>
-        </p:nvSpPr>
-        <p:spPr>
-          <a:xfrm>
-            <a:off x="6537960" y="3337560"/>
-            <a:ext cx="4892040" cy="2743200"/>
-          </a:xfrm>
-          <a:prstGeom prst="rect">
-            <a:avLst/>
-          </a:prstGeom>
-          <a:noFill/>
-        </p:spPr>
-        <p:txBody>
-          <a:bodyPr wrap="square" lIns="0" tIns="0" rIns="0" bIns="0" anchor="t">
-            <a:spAutoFit/>
-          </a:bodyPr>
-          <a:lstStyle/>
+              <a:t>, convert directly to </a:t>
+            </a:r>
+            <a:r>
+              <a:rPr lang="en-US" sz="1300" b="0" i="0" dirty="0">
+                <a:solidFill>
+                  <a:srgbClr val="1A1F2B"/>
+                </a:solidFill>
+                <a:latin typeface="Calibri"/>
+              </a:rPr>
+              <a:t>Python</a:t>
+            </a:r>
+            <a:endParaRPr sz="1300" b="0" i="0" dirty="0">
+              <a:solidFill>
+                <a:srgbClr val="1A1F2B"/>
+              </a:solidFill>
+              <a:latin typeface="Calibri"/>
+            </a:endParaRPr>
+          </a:p>
           <a:p>
             <a:pPr marL="0" indent="0" algn="l">
               <a:lnSpc>
@@ -7499,7 +7741,7 @@
               </a:spcAft>
             </a:pPr>
             <a:r>
-              <a:rPr sz="1300" b="1">
+              <a:rPr sz="1300" b="1" dirty="0">
                 <a:solidFill>
                   <a:srgbClr val="1F7A8C"/>
                 </a:solidFill>
@@ -7508,13 +7750,31 @@
               <a:t>▪  </a:t>
             </a:r>
             <a:r>
-              <a:rPr sz="1300" b="0" i="0">
+              <a:rPr sz="1300" b="0" i="0" dirty="0">
                 <a:solidFill>
                   <a:srgbClr val="1A1F2B"/>
                 </a:solidFill>
                 <a:latin typeface="Calibri"/>
               </a:rPr>
-              <a:t>ASR (Whisper) — speak a natural-language prompt → transcribed → code generated (NL → PL)</a:t>
+              <a:t>Auto task-detection — LLM classifier routes input to the correct </a:t>
+            </a:r>
+            <a:r>
+              <a:rPr sz="1300" b="0" i="0" dirty="0" err="1">
+                <a:solidFill>
+                  <a:srgbClr val="1A1F2B"/>
+                </a:solidFill>
+                <a:latin typeface="Calibri"/>
+              </a:rPr>
+              <a:t>LoRA</a:t>
+            </a:r>
+            <a:r>
+              <a:rPr sz="1300" b="0" i="0" dirty="0">
+                <a:solidFill>
+                  <a:srgbClr val="1A1F2B"/>
+                </a:solidFill>
+                <a:latin typeface="Calibri"/>
+              </a:rPr>
+              <a:t> adapter</a:t>
             </a:r>
           </a:p>
           <a:p>
@@ -7527,7 +7787,7 @@
               </a:spcAft>
             </a:pPr>
             <a:r>
-              <a:rPr sz="1300" b="1">
+              <a:rPr sz="1300" b="1" dirty="0">
                 <a:solidFill>
                   <a:srgbClr val="1F7A8C"/>
                 </a:solidFill>
@@ -7536,69 +7796,31 @@
               <a:t>▪  </a:t>
             </a:r>
             <a:r>
-              <a:rPr sz="1300" b="0" i="0">
+              <a:rPr sz="1300" b="0" i="0" dirty="0">
                 <a:solidFill>
                   <a:srgbClr val="1A1F2B"/>
                 </a:solidFill>
                 <a:latin typeface="Calibri"/>
               </a:rPr>
-              <a:t>Text interface for PL → PL — paste Python, convert directly to C++</a:t>
-            </a:r>
-          </a:p>
-          <a:p>
-            <a:pPr marL="0" indent="0" algn="l">
-              <a:lnSpc>
-                <a:spcPct val="108000"/>
-              </a:lnSpc>
-              <a:spcAft>
-                <a:spcPts val="800"/>
-              </a:spcAft>
-            </a:pPr>
-            <a:r>
-              <a:rPr sz="1300" b="1">
-                <a:solidFill>
-                  <a:srgbClr val="1F7A8C"/>
-                </a:solidFill>
-                <a:latin typeface="Calibri"/>
-              </a:rPr>
-              <a:t>▪  </a:t>
-            </a:r>
-            <a:r>
-              <a:rPr sz="1300" b="0" i="0">
+              <a:t>Delivered as a live, voice-enabled </a:t>
+            </a:r>
+            <a:r>
+              <a:rPr sz="1300" b="0" i="0" dirty="0" err="1">
                 <a:solidFill>
                   <a:srgbClr val="1A1F2B"/>
                 </a:solidFill>
                 <a:latin typeface="Calibri"/>
               </a:rPr>
-              <a:t>Auto task-detection — LLM classifier routes input to the correct LoRA adapter</a:t>
-            </a:r>
-          </a:p>
-          <a:p>
-            <a:pPr marL="0" indent="0" algn="l">
-              <a:lnSpc>
-                <a:spcPct val="108000"/>
-              </a:lnSpc>
-              <a:spcAft>
-                <a:spcPts val="800"/>
-              </a:spcAft>
-            </a:pPr>
-            <a:r>
-              <a:rPr sz="1300" b="1">
-                <a:solidFill>
-                  <a:srgbClr val="1F7A8C"/>
-                </a:solidFill>
-                <a:latin typeface="Calibri"/>
-              </a:rPr>
-              <a:t>▪  </a:t>
-            </a:r>
-            <a:r>
-              <a:rPr sz="1300" b="0" i="0">
+              <a:t>Gradio</a:t>
+            </a:r>
+            <a:r>
+              <a:rPr sz="1300" b="0" i="0" dirty="0">
                 <a:solidFill>
                   <a:srgbClr val="1A1F2B"/>
                 </a:solidFill>
                 <a:latin typeface="Calibri"/>
               </a:rPr>
-              <a:t>Delivered as a live, voice-enabled Gradio web application</a:t>
+              <a:t> web application</a:t>
             </a:r>
           </a:p>
         </p:txBody>
@@ -8745,7 +8967,7 @@
         <p:spPr>
           <a:xfrm>
             <a:off x="502920" y="4617720"/>
-            <a:ext cx="11155680" cy="1828800"/>
+            <a:ext cx="11155680" cy="1690847"/>
           </a:xfrm>
           <a:prstGeom prst="rect">
             <a:avLst/>
@@ -8767,7 +8989,7 @@
               </a:spcAft>
             </a:pPr>
             <a:r>
-              <a:rPr sz="1300" b="1">
+              <a:rPr sz="1300" b="1" dirty="0">
                 <a:solidFill>
                   <a:srgbClr val="1F7A8C"/>
                 </a:solidFill>
@@ -8776,7 +8998,7 @@
               <a:t>▪  </a:t>
             </a:r>
             <a:r>
-              <a:rPr sz="1300" b="1">
+              <a:rPr sz="1300" b="1" dirty="0" err="1">
                 <a:solidFill>
                   <a:srgbClr val="0F2A4A"/>
                 </a:solidFill>
@@ -8785,14 +9007,38 @@
               <a:t>SingletonMeta</a:t>
             </a:r>
             <a:r>
-              <a:rPr sz="1300" b="0" i="0">
+              <a:rPr lang="en-US" sz="1300" b="1" dirty="0">
+                <a:solidFill>
+                  <a:srgbClr val="0F2A4A"/>
+                </a:solidFill>
+                <a:latin typeface="Calibri"/>
+              </a:rPr>
+              <a:t> </a:t>
+            </a:r>
+            <a:r>
+              <a:rPr sz="1300" b="0" i="0" dirty="0">
                 <a:solidFill>
                   <a:srgbClr val="1A1F2B"/>
                 </a:solidFill>
                 <a:latin typeface="Calibri"/>
               </a:rPr>
-              <a:t>Every heavyweight component — </a:t>
-            </a:r>
+              <a:t>Every heavyweight component</a:t>
+            </a:r>
+            <a:r>
+              <a:rPr lang="en-US" sz="1300" b="0" i="0" dirty="0">
+                <a:solidFill>
+                  <a:srgbClr val="1A1F2B"/>
+                </a:solidFill>
+                <a:latin typeface="Calibri"/>
+              </a:rPr>
+              <a:t>: </a:t>
+            </a:r>
+            <a:endParaRPr sz="1300" b="0" i="0" dirty="0">
+              <a:solidFill>
+                <a:srgbClr val="1A1F2B"/>
+              </a:solidFill>
+              <a:latin typeface="Calibri"/>
+            </a:endParaRPr>
           </a:p>
           <a:p>
             <a:pPr marL="0" indent="0" algn="l">
@@ -8804,22 +9050,166 @@
               </a:spcAft>
             </a:pPr>
             <a:r>
-              <a:rPr sz="1300" b="1">
+              <a:rPr lang="en-US" sz="1300" b="1" dirty="0">
                 <a:solidFill>
                   <a:srgbClr val="1F7A8C"/>
                 </a:solidFill>
                 <a:latin typeface="Calibri"/>
               </a:rPr>
+              <a:t>	</a:t>
+            </a:r>
+            <a:r>
+              <a:rPr sz="1300" b="1" dirty="0">
+                <a:solidFill>
+                  <a:srgbClr val="1F7A8C"/>
+                </a:solidFill>
+                <a:latin typeface="Calibri"/>
+              </a:rPr>
               <a:t>▪  </a:t>
             </a:r>
             <a:r>
-              <a:rPr sz="1300" b="0" i="0">
+              <a:rPr sz="1300" b="0" i="0" dirty="0" err="1">
                 <a:solidFill>
                   <a:srgbClr val="1A1F2B"/>
                 </a:solidFill>
                 <a:latin typeface="Calibri"/>
               </a:rPr>
-              <a:t>QwenModelBase, CodeDocumentationGenerator, QwenCodeGenerator, LLMJudge, AST, GraphCodeBERTScorer, FilteredDataset, BaselineData — is implemented as a singleton</a:t>
+              <a:t>QwenModelBase</a:t>
+            </a:r>
+            <a:r>
+              <a:rPr sz="1300" b="0" i="0" dirty="0">
+                <a:solidFill>
+                  <a:srgbClr val="1A1F2B"/>
+                </a:solidFill>
+                <a:latin typeface="Calibri"/>
+              </a:rPr>
+              <a:t>, </a:t>
+            </a:r>
+            <a:r>
+              <a:rPr sz="1300" b="0" i="0" dirty="0" err="1">
+                <a:solidFill>
+                  <a:srgbClr val="1A1F2B"/>
+                </a:solidFill>
+                <a:latin typeface="Calibri"/>
+              </a:rPr>
+              <a:t>CodeDocumentationGenerator</a:t>
+            </a:r>
+            <a:r>
+              <a:rPr sz="1300" b="0" i="0" dirty="0">
+                <a:solidFill>
+                  <a:srgbClr val="1A1F2B"/>
+                </a:solidFill>
+                <a:latin typeface="Calibri"/>
+              </a:rPr>
+              <a:t>, </a:t>
+            </a:r>
+            <a:r>
+              <a:rPr sz="1300" b="0" i="0" dirty="0" err="1">
+                <a:solidFill>
+                  <a:srgbClr val="1A1F2B"/>
+                </a:solidFill>
+                <a:latin typeface="Calibri"/>
+              </a:rPr>
+              <a:t>QwenCodeGenerator</a:t>
+            </a:r>
+            <a:r>
+              <a:rPr sz="1300" b="0" i="0" dirty="0">
+                <a:solidFill>
+                  <a:srgbClr val="1A1F2B"/>
+                </a:solidFill>
+                <a:latin typeface="Calibri"/>
+              </a:rPr>
+              <a:t>, </a:t>
+            </a:r>
+            <a:r>
+              <a:rPr sz="1300" b="0" i="0" dirty="0" err="1">
+                <a:solidFill>
+                  <a:srgbClr val="1A1F2B"/>
+                </a:solidFill>
+                <a:latin typeface="Calibri"/>
+              </a:rPr>
+              <a:t>LLMJudge</a:t>
+            </a:r>
+            <a:r>
+              <a:rPr sz="1300" b="0" i="0" dirty="0">
+                <a:solidFill>
+                  <a:srgbClr val="1A1F2B"/>
+                </a:solidFill>
+                <a:latin typeface="Calibri"/>
+              </a:rPr>
+              <a:t>, AST, </a:t>
+            </a:r>
+            <a:r>
+              <a:rPr sz="1300" b="0" i="0" dirty="0" err="1">
+                <a:solidFill>
+                  <a:srgbClr val="1A1F2B"/>
+                </a:solidFill>
+                <a:latin typeface="Calibri"/>
+              </a:rPr>
+              <a:t>GraphCodeBERTScorer</a:t>
+            </a:r>
+            <a:r>
+              <a:rPr sz="1300" b="0" i="0" dirty="0">
+                <a:solidFill>
+                  <a:srgbClr val="1A1F2B"/>
+                </a:solidFill>
+                <a:latin typeface="Calibri"/>
+              </a:rPr>
+              <a:t>, </a:t>
+            </a:r>
+            <a:r>
+              <a:rPr sz="1300" b="0" i="0" dirty="0" err="1">
+                <a:solidFill>
+                  <a:srgbClr val="1A1F2B"/>
+                </a:solidFill>
+                <a:latin typeface="Calibri"/>
+              </a:rPr>
+              <a:t>FilteredDataset</a:t>
+            </a:r>
+            <a:r>
+              <a:rPr sz="1300" b="0" i="0" dirty="0">
+                <a:solidFill>
+                  <a:srgbClr val="1A1F2B"/>
+                </a:solidFill>
+                <a:latin typeface="Calibri"/>
+              </a:rPr>
+              <a:t>, </a:t>
+            </a:r>
+            <a:r>
+              <a:rPr sz="1300" b="0" i="0" dirty="0" err="1">
+                <a:solidFill>
+                  <a:srgbClr val="1A1F2B"/>
+                </a:solidFill>
+                <a:latin typeface="Calibri"/>
+              </a:rPr>
+              <a:t>BaselineData</a:t>
+            </a:r>
+            <a:r>
+              <a:rPr sz="1300" b="0" i="0" dirty="0">
+                <a:solidFill>
+                  <a:srgbClr val="1A1F2B"/>
+                </a:solidFill>
+                <a:latin typeface="Calibri"/>
+              </a:rPr>
+              <a:t> — is </a:t>
+            </a:r>
+            <a:r>
+              <a:rPr lang="en-US" sz="1300" b="0" i="0" dirty="0">
+                <a:solidFill>
+                  <a:srgbClr val="1A1F2B"/>
+                </a:solidFill>
+                <a:latin typeface="Calibri"/>
+              </a:rPr>
+              <a:t>				</a:t>
+            </a:r>
+            <a:r>
+              <a:rPr sz="1300" b="0" i="0" dirty="0">
+                <a:solidFill>
+                  <a:srgbClr val="1A1F2B"/>
+                </a:solidFill>
+                <a:latin typeface="Calibri"/>
+              </a:rPr>
+              <a:t>implemented as a singleton</a:t>
             </a:r>
           </a:p>
           <a:p>
@@ -8832,7 +9222,7 @@
               </a:spcAft>
             </a:pPr>
             <a:r>
-              <a:rPr sz="1300" b="1">
+              <a:rPr sz="1300" b="1" dirty="0">
                 <a:solidFill>
                   <a:srgbClr val="1F7A8C"/>
                 </a:solidFill>
@@ -8841,7 +9231,7 @@
               <a:t>▪  </a:t>
             </a:r>
             <a:r>
-              <a:rPr sz="1300" b="0" i="0">
+              <a:rPr sz="1300" b="0" i="0" dirty="0">
                 <a:solidFill>
                   <a:srgbClr val="1A1F2B"/>
                 </a:solidFill>
@@ -8860,7 +9250,7 @@
               </a:spcAft>
             </a:pPr>
             <a:r>
-              <a:rPr sz="1300" b="1">
+              <a:rPr sz="1300" b="1" dirty="0">
                 <a:solidFill>
                   <a:srgbClr val="1F7A8C"/>
                 </a:solidFill>
@@ -8869,13 +9259,119 @@
               <a:t>▪  </a:t>
             </a:r>
             <a:r>
-              <a:rPr sz="1300" b="0" i="0">
+              <a:rPr sz="1300" b="0" i="0" dirty="0" err="1">
                 <a:solidFill>
                   <a:srgbClr val="1A1F2B"/>
                 </a:solidFill>
                 <a:latin typeface="Calibri"/>
               </a:rPr>
-              <a:t>BaselineData orchestrates the full workflow: loads/unloads models, runs baseline + validation, computes summary statistics</a:t>
+              <a:t>BaselineData</a:t>
+            </a:r>
+            <a:r>
+              <a:rPr sz="1300" b="0" i="0" dirty="0">
+                <a:solidFill>
+                  <a:srgbClr val="1A1F2B"/>
+                </a:solidFill>
+                <a:latin typeface="Calibri"/>
+              </a:rPr>
+              <a:t> orchestrates the full workflow: loads/unloads models, runs baseline + validation, computes summary statistics</a:t>
+            </a:r>
+            <a:endParaRPr lang="en-US" sz="1300" b="0" i="0" dirty="0">
+              <a:solidFill>
+                <a:srgbClr val="1A1F2B"/>
+              </a:solidFill>
+              <a:latin typeface="Calibri"/>
+            </a:endParaRPr>
+          </a:p>
+          <a:p>
+            <a:r>
+              <a:rPr lang="en-US" sz="1300" b="1" dirty="0">
+                <a:solidFill>
+                  <a:srgbClr val="1F7A8C"/>
+                </a:solidFill>
+              </a:rPr>
+              <a:t>▪ </a:t>
+            </a:r>
+            <a:r>
+              <a:rPr lang="en-US" sz="1300" b="1" dirty="0">
+                <a:solidFill>
+                  <a:srgbClr val="1A1F2B"/>
+                </a:solidFill>
+                <a:latin typeface="Calibri"/>
+              </a:rPr>
+              <a:t>LLM Judge</a:t>
+            </a:r>
+            <a:r>
+              <a:rPr lang="en-US" sz="1300" dirty="0">
+                <a:solidFill>
+                  <a:srgbClr val="1A1F2B"/>
+                </a:solidFill>
+                <a:latin typeface="Calibri"/>
+              </a:rPr>
+              <a:t>: Generates Score 0.0 -1.0 and metrics compiles (Y/N),  correct logic (Y/N), handling edge cases (Y/N), List of issues and explanation</a:t>
+            </a:r>
+            <a:endParaRPr sz="1300" b="0" i="0" dirty="0">
+              <a:solidFill>
+                <a:srgbClr val="1A1F2B"/>
+              </a:solidFill>
+              <a:latin typeface="Calibri"/>
+            </a:endParaRPr>
+          </a:p>
+        </p:txBody>
+      </p:sp>
+      <p:sp>
+        <p:nvSpPr>
+          <p:cNvPr id="26" name="Rectangle: Rounded Corners 25">
+            <a:extLst>
+              <a:ext uri="{FF2B5EF4-FFF2-40B4-BE49-F238E27FC236}">
+                <a16:creationId xmlns:a16="http://schemas.microsoft.com/office/drawing/2014/main" id="{77CE622B-600D-0078-8A7E-8525BF4DC96A}"/>
+              </a:ext>
+            </a:extLst>
+          </p:cNvPr>
+          <p:cNvSpPr/>
+          <p:nvPr/>
+        </p:nvSpPr>
+        <p:spPr>
+          <a:xfrm>
+            <a:off x="4904900" y="2395728"/>
+            <a:ext cx="1244440" cy="347472"/>
+          </a:xfrm>
+          <a:prstGeom prst="roundRect">
+            <a:avLst/>
+          </a:prstGeom>
+          <a:ln>
+            <a:noFill/>
+          </a:ln>
+        </p:spPr>
+        <p:style>
+          <a:lnRef idx="1">
+            <a:schemeClr val="accent1"/>
+          </a:lnRef>
+          <a:fillRef idx="3">
+            <a:schemeClr val="accent1"/>
+          </a:fillRef>
+          <a:effectRef idx="2">
+            <a:schemeClr val="accent1"/>
+          </a:effectRef>
+          <a:fontRef idx="minor">
+            <a:schemeClr val="lt1"/>
+          </a:fontRef>
+        </p:style>
+        <p:txBody>
+          <a:bodyPr rtlCol="0" anchor="ctr"/>
+          <a:lstStyle/>
+          <a:p>
+            <a:pPr algn="ctr"/>
+            <a:r>
+              <a:rPr lang="en-US" sz="1200" dirty="0"/>
+              <a:t>LLM Judge</a:t>
+            </a:r>
+          </a:p>
+          <a:p>
+            <a:pPr algn="ctr"/>
+            <a:r>
+              <a:rPr lang="en-US" sz="1200" dirty="0"/>
+              <a:t>(doc-&gt;python)</a:t>
             </a:r>
           </a:p>
         </p:txBody>
@@ -9207,7 +9703,7 @@
         <p:spPr>
           <a:xfrm>
             <a:off x="502920" y="1645920"/>
-            <a:ext cx="5486400" cy="1554480"/>
+            <a:ext cx="5486400" cy="1234312"/>
           </a:xfrm>
           <a:prstGeom prst="rect">
             <a:avLst/>
@@ -9229,7 +9725,7 @@
               </a:spcAft>
             </a:pPr>
             <a:r>
-              <a:rPr sz="1250" b="1">
+              <a:rPr sz="1250" b="1" dirty="0">
                 <a:solidFill>
                   <a:srgbClr val="1F7A8C"/>
                 </a:solidFill>
@@ -9238,23 +9734,153 @@
               <a:t>▪  </a:t>
             </a:r>
             <a:r>
-              <a:rPr sz="1250" b="1">
+              <a:rPr sz="1250" b="1" dirty="0">
                 <a:solidFill>
                   <a:srgbClr val="0F2A4A"/>
                 </a:solidFill>
                 <a:latin typeface="Calibri"/>
               </a:rPr>
-              <a:t> (HuggingFace) — deduplicated Python &amp; C++ source files</a:t>
-            </a:r>
-            <a:r>
-              <a:rPr sz="1250" b="0" i="0">
+              <a:t> (</a:t>
+            </a:r>
+            <a:r>
+              <a:rPr sz="1250" b="1" dirty="0" err="1">
+                <a:solidFill>
+                  <a:srgbClr val="0F2A4A"/>
+                </a:solidFill>
+                <a:latin typeface="Calibri"/>
+              </a:rPr>
+              <a:t>HuggingFace</a:t>
+            </a:r>
+            <a:r>
+              <a:rPr sz="1250" b="1" dirty="0">
+                <a:solidFill>
+                  <a:srgbClr val="0F2A4A"/>
+                </a:solidFill>
+                <a:latin typeface="Calibri"/>
+              </a:rPr>
+              <a:t>) — deduplicated Python &amp; C++ source files</a:t>
+            </a:r>
+            <a:r>
+              <a:rPr lang="en-US" sz="1250" b="1" dirty="0">
+                <a:solidFill>
+                  <a:srgbClr val="0F2A4A"/>
+                </a:solidFill>
+                <a:latin typeface="Calibri"/>
+              </a:rPr>
+              <a:t> </a:t>
+            </a:r>
+            <a:r>
+              <a:rPr sz="1250" b="0" i="0" dirty="0" err="1">
                 <a:solidFill>
                   <a:srgbClr val="1A1F2B"/>
                 </a:solidFill>
                 <a:latin typeface="Calibri"/>
               </a:rPr>
-              <a:t>bigcode/the-stack-dedup</a:t>
-            </a:r>
+              <a:t>bigcode</a:t>
+            </a:r>
+            <a:r>
+              <a:rPr sz="1250" b="0" i="0" dirty="0">
+                <a:solidFill>
+                  <a:srgbClr val="1A1F2B"/>
+                </a:solidFill>
+                <a:latin typeface="Calibri"/>
+              </a:rPr>
+              <a:t>/the-stack-</a:t>
+            </a:r>
+            <a:r>
+              <a:rPr sz="1250" b="0" i="0" dirty="0" err="1">
+                <a:solidFill>
+                  <a:srgbClr val="1A1F2B"/>
+                </a:solidFill>
+                <a:latin typeface="Calibri"/>
+              </a:rPr>
+              <a:t>dedup</a:t>
+            </a:r>
+            <a:endParaRPr lang="en-US" sz="1250" b="0" i="0" dirty="0">
+              <a:solidFill>
+                <a:srgbClr val="1A1F2B"/>
+              </a:solidFill>
+              <a:latin typeface="Calibri"/>
+            </a:endParaRPr>
+          </a:p>
+          <a:p>
+            <a:pPr>
+              <a:lnSpc>
+                <a:spcPct val="108000"/>
+              </a:lnSpc>
+              <a:spcAft>
+                <a:spcPts val="800"/>
+              </a:spcAft>
+            </a:pPr>
+            <a:r>
+              <a:rPr sz="1250" b="1" dirty="0">
+                <a:solidFill>
+                  <a:srgbClr val="002060"/>
+                </a:solidFill>
+                <a:latin typeface="Calibri"/>
+              </a:rPr>
+              <a:t>▪  </a:t>
+            </a:r>
+            <a:r>
+              <a:rPr lang="en-US" sz="1250" b="1" dirty="0" err="1">
+                <a:solidFill>
+                  <a:srgbClr val="002060"/>
+                </a:solidFill>
+                <a:latin typeface="Calibri"/>
+              </a:rPr>
+              <a:t>Fileds</a:t>
+            </a:r>
+            <a:r>
+              <a:rPr lang="en-US" sz="1250" b="1" dirty="0">
+                <a:solidFill>
+                  <a:srgbClr val="002060"/>
+                </a:solidFill>
+                <a:latin typeface="Calibri"/>
+              </a:rPr>
+              <a:t> Used: </a:t>
+            </a:r>
+            <a:r>
+              <a:rPr sz="1250" b="1" dirty="0" err="1">
+                <a:solidFill>
+                  <a:srgbClr val="002060"/>
+                </a:solidFill>
+                <a:latin typeface="Calibri"/>
+              </a:rPr>
+              <a:t>hexsha</a:t>
+            </a:r>
+            <a:r>
+              <a:rPr sz="1250" b="1" dirty="0">
+                <a:solidFill>
+                  <a:srgbClr val="002060"/>
+                </a:solidFill>
+                <a:latin typeface="Calibri"/>
+              </a:rPr>
+              <a:t> (id</a:t>
+            </a:r>
+            <a:r>
+              <a:rPr sz="1250" b="1" dirty="0">
+                <a:solidFill>
+                  <a:srgbClr val="0F2A4A"/>
+                </a:solidFill>
+                <a:latin typeface="Calibri"/>
+              </a:rPr>
+              <a:t>), content (code), lang, </a:t>
+            </a:r>
+            <a:r>
+              <a:rPr sz="1250" b="1" dirty="0" err="1">
+                <a:solidFill>
+                  <a:srgbClr val="0F2A4A"/>
+                </a:solidFill>
+                <a:latin typeface="Calibri"/>
+              </a:rPr>
+              <a:t>max_stars_count</a:t>
+            </a:r>
+            <a:endParaRPr sz="1250" b="0" i="0" dirty="0">
+              <a:solidFill>
+                <a:srgbClr val="1A1F2B"/>
+              </a:solidFill>
+              <a:latin typeface="Calibri"/>
+            </a:endParaRPr>
           </a:p>
           <a:p>
             <a:pPr marL="0" indent="0" algn="l">
@@ -9266,7 +9892,7 @@
               </a:spcAft>
             </a:pPr>
             <a:r>
-              <a:rPr sz="1250" b="1">
+              <a:rPr sz="1250" b="1" dirty="0">
                 <a:solidFill>
                   <a:srgbClr val="1F7A8C"/>
                 </a:solidFill>
@@ -9275,24 +9901,95 @@
               <a:t>▪  </a:t>
             </a:r>
             <a:r>
-              <a:rPr sz="1250" b="1">
+              <a:rPr sz="1250" b="0" i="0" dirty="0">
+                <a:solidFill>
+                  <a:srgbClr val="1A1F2B"/>
+                </a:solidFill>
+                <a:latin typeface="Calibri"/>
+              </a:rPr>
+              <a:t>Streamed, filtered </a:t>
+            </a:r>
+            <a:r>
+              <a:rPr lang="en-US" sz="1250" b="0" i="0" dirty="0">
+                <a:solidFill>
+                  <a:srgbClr val="1A1F2B"/>
+                </a:solidFill>
+                <a:latin typeface="Calibri"/>
+              </a:rPr>
+              <a:t>by</a:t>
+            </a:r>
+            <a:r>
+              <a:rPr sz="1250" b="0" i="0" dirty="0">
+                <a:solidFill>
+                  <a:srgbClr val="1A1F2B"/>
+                </a:solidFill>
+                <a:latin typeface="Calibri"/>
+              </a:rPr>
+              <a:t> Python/C++, then enriched (language tag, documentation cache, score placeholders)</a:t>
+            </a:r>
+          </a:p>
+        </p:txBody>
+      </p:sp>
+      <p:sp>
+        <p:nvSpPr>
+          <p:cNvPr id="10" name="TextBox 9"/>
+          <p:cNvSpPr txBox="1"/>
+          <p:nvPr/>
+        </p:nvSpPr>
+        <p:spPr>
+          <a:xfrm>
+            <a:off x="502920" y="3063240"/>
+            <a:ext cx="5486400" cy="320040"/>
+          </a:xfrm>
+          <a:prstGeom prst="rect">
+            <a:avLst/>
+          </a:prstGeom>
+          <a:noFill/>
+        </p:spPr>
+        <p:txBody>
+          <a:bodyPr wrap="square" lIns="0" tIns="0" rIns="0" bIns="0" anchor="t">
+            <a:spAutoFit/>
+          </a:bodyPr>
+          <a:lstStyle/>
+          <a:p>
+            <a:pPr algn="l">
+              <a:lnSpc>
+                <a:spcPct val="100000"/>
+              </a:lnSpc>
+            </a:pPr>
+            <a:r>
+              <a:rPr sz="1500" b="1" i="0" dirty="0">
                 <a:solidFill>
                   <a:srgbClr val="0F2A4A"/>
                 </a:solidFill>
                 <a:latin typeface="Calibri"/>
               </a:rPr>
-              <a:t>hexsha (id), content (code), lang, max_stars_count</a:t>
-            </a:r>
-            <a:r>
-              <a:rPr sz="1250" b="0" i="0">
-                <a:solidFill>
-                  <a:srgbClr val="1A1F2B"/>
-                </a:solidFill>
-                <a:latin typeface="Calibri"/>
-              </a:rPr>
-              <a:t>Fields used: </a:t>
-            </a:r>
-          </a:p>
+              <a:t>Why Caching Matters</a:t>
+            </a:r>
+          </a:p>
+        </p:txBody>
+      </p:sp>
+      <p:sp>
+        <p:nvSpPr>
+          <p:cNvPr id="11" name="TextBox 10"/>
+          <p:cNvSpPr txBox="1"/>
+          <p:nvPr/>
+        </p:nvSpPr>
+        <p:spPr>
+          <a:xfrm>
+            <a:off x="502920" y="3429000"/>
+            <a:ext cx="5486400" cy="1463040"/>
+          </a:xfrm>
+          <a:prstGeom prst="rect">
+            <a:avLst/>
+          </a:prstGeom>
+          <a:noFill/>
+        </p:spPr>
+        <p:txBody>
+          <a:bodyPr wrap="square" lIns="0" tIns="0" rIns="0" bIns="0" anchor="t">
+            <a:spAutoFit/>
+          </a:bodyPr>
+          <a:lstStyle/>
           <a:p>
             <a:pPr marL="0" indent="0" algn="l">
               <a:lnSpc>
@@ -9303,7 +10000,7 @@
               </a:spcAft>
             </a:pPr>
             <a:r>
-              <a:rPr sz="1250" b="1">
+              <a:rPr sz="1250" b="1" dirty="0">
                 <a:solidFill>
                   <a:srgbClr val="1F7A8C"/>
                 </a:solidFill>
@@ -9312,77 +10009,33 @@
               <a:t>▪  </a:t>
             </a:r>
             <a:r>
-              <a:rPr sz="1250" b="0" i="0">
+              <a:rPr sz="1250" b="0" i="0" dirty="0">
                 <a:solidFill>
                   <a:srgbClr val="1A1F2B"/>
                 </a:solidFill>
                 <a:latin typeface="Calibri"/>
               </a:rPr>
-              <a:t>Streamed, filtered to Python/C++, then enriched (language tag, documentation cache, score placeholders)</a:t>
-            </a:r>
-          </a:p>
-        </p:txBody>
-      </p:sp>
-      <p:sp>
-        <p:nvSpPr>
-          <p:cNvPr id="10" name="TextBox 9"/>
-          <p:cNvSpPr txBox="1"/>
-          <p:nvPr/>
-        </p:nvSpPr>
-        <p:spPr>
-          <a:xfrm>
-            <a:off x="502920" y="3063240"/>
-            <a:ext cx="5486400" cy="320040"/>
-          </a:xfrm>
-          <a:prstGeom prst="rect">
-            <a:avLst/>
-          </a:prstGeom>
-          <a:noFill/>
-        </p:spPr>
-        <p:txBody>
-          <a:bodyPr wrap="square" lIns="0" tIns="0" rIns="0" bIns="0" anchor="t">
-            <a:spAutoFit/>
-          </a:bodyPr>
-          <a:lstStyle/>
-          <a:p>
-            <a:pPr algn="l">
-              <a:lnSpc>
-                <a:spcPct val="100000"/>
-              </a:lnSpc>
-            </a:pPr>
-            <a:r>
-              <a:rPr sz="1500" b="1" i="0">
-                <a:solidFill>
-                  <a:srgbClr val="0F2A4A"/>
-                </a:solidFill>
-                <a:latin typeface="Calibri"/>
-              </a:rPr>
-              <a:t>Why Caching Matters</a:t>
-            </a:r>
-          </a:p>
-        </p:txBody>
-      </p:sp>
-      <p:sp>
-        <p:nvSpPr>
-          <p:cNvPr id="11" name="TextBox 10"/>
-          <p:cNvSpPr txBox="1"/>
-          <p:nvPr/>
-        </p:nvSpPr>
-        <p:spPr>
-          <a:xfrm>
-            <a:off x="502920" y="3429000"/>
-            <a:ext cx="5486400" cy="1463040"/>
-          </a:xfrm>
-          <a:prstGeom prst="rect">
-            <a:avLst/>
-          </a:prstGeom>
-          <a:noFill/>
-        </p:spPr>
-        <p:txBody>
-          <a:bodyPr wrap="square" lIns="0" tIns="0" rIns="0" bIns="0" anchor="t">
-            <a:spAutoFit/>
-          </a:bodyPr>
-          <a:lstStyle/>
+              <a:t>Streaming from </a:t>
+            </a:r>
+            <a:r>
+              <a:rPr sz="1250" b="0" i="0" dirty="0" err="1">
+                <a:solidFill>
+                  <a:srgbClr val="1A1F2B"/>
+                </a:solidFill>
+                <a:latin typeface="Calibri"/>
+              </a:rPr>
+              <a:t>HuggingFace</a:t>
+            </a:r>
+            <a:r>
+              <a:rPr sz="1250" b="0" i="0" dirty="0">
+                <a:solidFill>
+                  <a:srgbClr val="1A1F2B"/>
+                </a:solidFill>
+                <a:latin typeface="Calibri"/>
+              </a:rPr>
+              <a:t> on every pass is slow — caching gives instant reloads</a:t>
+            </a:r>
+          </a:p>
           <a:p>
             <a:pPr marL="0" indent="0" algn="l">
               <a:lnSpc>
@@ -9393,7 +10046,7 @@
               </a:spcAft>
             </a:pPr>
             <a:r>
-              <a:rPr sz="1250" b="1">
+              <a:rPr sz="1250" b="1" dirty="0">
                 <a:solidFill>
                   <a:srgbClr val="1F7A8C"/>
                 </a:solidFill>
@@ -9402,13 +10055,13 @@
               <a:t>▪  </a:t>
             </a:r>
             <a:r>
-              <a:rPr sz="1250" b="0" i="0">
+              <a:rPr sz="1250" b="0" i="0" dirty="0">
                 <a:solidFill>
                   <a:srgbClr val="1A1F2B"/>
                 </a:solidFill>
                 <a:latin typeface="Calibri"/>
               </a:rPr>
-              <a:t>Streaming from HuggingFace on every pass is slow — caching gives instant reloads</a:t>
+              <a:t>Baseline computation needs multiple passes over the same records</a:t>
             </a:r>
           </a:p>
           <a:p>
@@ -9421,7 +10074,7 @@
               </a:spcAft>
             </a:pPr>
             <a:r>
-              <a:rPr sz="1250" b="1">
+              <a:rPr sz="1250" b="1" dirty="0">
                 <a:solidFill>
                   <a:srgbClr val="1F7A8C"/>
                 </a:solidFill>
@@ -9430,35 +10083,7 @@
               <a:t>▪  </a:t>
             </a:r>
             <a:r>
-              <a:rPr sz="1250" b="0" i="0">
-                <a:solidFill>
-                  <a:srgbClr val="1A1F2B"/>
-                </a:solidFill>
-                <a:latin typeface="Calibri"/>
-              </a:rPr>
-              <a:t>Baseline computation needs multiple passes over the same records</a:t>
-            </a:r>
-          </a:p>
-          <a:p>
-            <a:pPr marL="0" indent="0" algn="l">
-              <a:lnSpc>
-                <a:spcPct val="108000"/>
-              </a:lnSpc>
-              <a:spcAft>
-                <a:spcPts val="800"/>
-              </a:spcAft>
-            </a:pPr>
-            <a:r>
-              <a:rPr sz="1250" b="1">
-                <a:solidFill>
-                  <a:srgbClr val="1F7A8C"/>
-                </a:solidFill>
-                <a:latin typeface="Calibri"/>
-              </a:rPr>
-              <a:t>▪  </a:t>
-            </a:r>
-            <a:r>
-              <a:rPr sz="1250" b="0" i="0">
+              <a:rPr sz="1250" b="0" i="0" dirty="0">
                 <a:solidFill>
                   <a:srgbClr val="1A1F2B"/>
                 </a:solidFill>
@@ -9478,7 +10103,7 @@
         <p:spPr>
           <a:xfrm>
             <a:off x="6400800" y="1280160"/>
-            <a:ext cx="5257800" cy="320040"/>
+            <a:ext cx="5257800" cy="230832"/>
           </a:xfrm>
           <a:prstGeom prst="rect">
             <a:avLst/>
@@ -9497,14 +10122,38 @@
               </a:lnSpc>
             </a:pPr>
             <a:r>
-              <a:rPr sz="1500" b="1" i="0">
+              <a:rPr sz="1500" b="1" i="0" dirty="0">
                 <a:solidFill>
                   <a:srgbClr val="0F2A4A"/>
                 </a:solidFill>
                 <a:latin typeface="Calibri"/>
               </a:rPr>
-              <a:t>Dataset Split (equal thirds)</a:t>
-            </a:r>
+              <a:t>Dataset Split</a:t>
+            </a:r>
+            <a:r>
+              <a:rPr lang="en-US" sz="1500" b="1" i="0" dirty="0">
+                <a:solidFill>
+                  <a:srgbClr val="0F2A4A"/>
+                </a:solidFill>
+                <a:latin typeface="Calibri"/>
+              </a:rPr>
+              <a:t> </a:t>
+            </a:r>
+            <a:r>
+              <a:rPr lang="en-US" sz="1000" b="1" dirty="0">
+                <a:solidFill>
+                  <a:srgbClr val="0F2A4A"/>
+                </a:solidFill>
+                <a:latin typeface="Calibri"/>
+              </a:rPr>
+              <a:t>Allocate more records for trainings</a:t>
+            </a:r>
+            <a:endParaRPr sz="1500" b="1" i="0" strike="sngStrike" dirty="0">
+              <a:solidFill>
+                <a:srgbClr val="0F2A4A"/>
+              </a:solidFill>
+              <a:latin typeface="Calibri"/>
+            </a:endParaRPr>
           </a:p>
         </p:txBody>
       </p:sp>
@@ -9514,7 +10163,13 @@
           <p:cNvGraphicFramePr>
             <a:graphicFrameLocks noGrp="1"/>
           </p:cNvGraphicFramePr>
-          <p:nvPr/>
+          <p:nvPr>
+            <p:extLst>
+              <p:ext uri="{D42A27DB-BD31-4B8C-83A1-F6EECF244321}">
+                <p14:modId xmlns:p14="http://schemas.microsoft.com/office/powerpoint/2010/main" val="1040076882"/>
+              </p:ext>
+            </p:extLst>
+          </p:nvPr>
         </p:nvGraphicFramePr>
         <p:xfrm>
           <a:off x="6400800" y="1645920"/>
@@ -9603,7 +10258,7 @@
                     <a:p>
                       <a:pPr algn="l"/>
                       <a:r>
-                        <a:rPr sz="1250" b="1">
+                        <a:rPr sz="1250" b="1" dirty="0">
                           <a:solidFill>
                             <a:srgbClr val="FFFFFF"/>
                           </a:solidFill>
@@ -9632,7 +10287,7 @@
                     <a:lstStyle/>
                     <a:p>
                       <a:r>
-                        <a:rPr sz="1200">
+                        <a:rPr sz="1200" dirty="0">
                           <a:solidFill>
                             <a:srgbClr val="1A1F2B"/>
                           </a:solidFill>
@@ -9654,14 +10309,20 @@
                     <a:lstStyle/>
                     <a:p>
                       <a:r>
-                        <a:rPr sz="1200">
+                        <a:rPr lang="en-US" sz="1200" dirty="0">
                           <a:solidFill>
-                            <a:srgbClr val="1A1F2B"/>
+                            <a:srgbClr val="002060"/>
                           </a:solidFill>
                           <a:latin typeface="Calibri"/>
                         </a:rPr>
-                        <a:t>1/3</a:t>
+                        <a:t>1/4</a:t>
                       </a:r>
+                      <a:endParaRPr sz="1200" dirty="0">
+                        <a:solidFill>
+                          <a:srgbClr val="002060"/>
+                        </a:solidFill>
+                        <a:latin typeface="Calibri"/>
+                      </a:endParaRPr>
                     </a:p>
                   </a:txBody>
                   <a:tcPr anchor="ctr">
@@ -9676,7 +10337,7 @@
                     <a:lstStyle/>
                     <a:p>
                       <a:r>
-                        <a:rPr sz="1200">
+                        <a:rPr sz="1200" dirty="0">
                           <a:solidFill>
                             <a:srgbClr val="1A1F2B"/>
                           </a:solidFill>
@@ -9727,14 +10388,20 @@
                     <a:lstStyle/>
                     <a:p>
                       <a:r>
-                        <a:rPr sz="1200">
+                        <a:rPr lang="en-US" sz="1200" dirty="0">
                           <a:solidFill>
-                            <a:srgbClr val="1A1F2B"/>
+                            <a:srgbClr val="002060"/>
                           </a:solidFill>
                           <a:latin typeface="Calibri"/>
                         </a:rPr>
-                        <a:t>1/3</a:t>
+                        <a:t>1/2</a:t>
                       </a:r>
+                      <a:endParaRPr sz="1200" dirty="0">
+                        <a:solidFill>
+                          <a:srgbClr val="002060"/>
+                        </a:solidFill>
+                        <a:latin typeface="Calibri"/>
+                      </a:endParaRPr>
                     </a:p>
                   </a:txBody>
                   <a:tcPr anchor="ctr">
@@ -9800,14 +10467,20 @@
                     <a:lstStyle/>
                     <a:p>
                       <a:r>
-                        <a:rPr sz="1200">
+                        <a:rPr lang="en-US" sz="1200" dirty="0">
                           <a:solidFill>
-                            <a:srgbClr val="1A1F2B"/>
+                            <a:srgbClr val="002060"/>
                           </a:solidFill>
                           <a:latin typeface="Calibri"/>
                         </a:rPr>
-                        <a:t>1/3</a:t>
+                        <a:t>1/4</a:t>
                       </a:r>
+                      <a:endParaRPr sz="1200" dirty="0">
+                        <a:solidFill>
+                          <a:srgbClr val="002060"/>
+                        </a:solidFill>
+                        <a:latin typeface="Calibri"/>
+                      </a:endParaRPr>
                     </a:p>
                   </a:txBody>
                   <a:tcPr anchor="ctr">
@@ -9822,7 +10495,7 @@
                     <a:lstStyle/>
                     <a:p>
                       <a:r>
-                        <a:rPr sz="1200">
+                        <a:rPr sz="1200" dirty="0">
                           <a:solidFill>
                             <a:srgbClr val="1A1F2B"/>
                           </a:solidFill>
@@ -9896,7 +10569,7 @@
         <p:spPr>
           <a:xfrm>
             <a:off x="6400800" y="3886200"/>
-            <a:ext cx="5257800" cy="1463040"/>
+            <a:ext cx="5257800" cy="1026563"/>
           </a:xfrm>
           <a:prstGeom prst="rect">
             <a:avLst/>
@@ -9918,7 +10591,7 @@
               </a:spcAft>
             </a:pPr>
             <a:r>
-              <a:rPr sz="1250" b="1">
+              <a:rPr sz="1250" b="1" dirty="0">
                 <a:solidFill>
                   <a:srgbClr val="1F7A8C"/>
                 </a:solidFill>
@@ -9927,7 +10600,7 @@
               <a:t>▪  </a:t>
             </a:r>
             <a:r>
-              <a:rPr sz="1250" b="1">
+              <a:rPr sz="1250" b="1" dirty="0">
                 <a:solidFill>
                   <a:srgbClr val="0F2A4A"/>
                 </a:solidFill>
@@ -9936,14 +10609,20 @@
               <a:t>Baseline records processed: </a:t>
             </a:r>
             <a:r>
-              <a:rPr sz="1250" b="0" i="0">
-                <a:solidFill>
-                  <a:srgbClr val="1A1F2B"/>
-                </a:solidFill>
-                <a:latin typeface="Calibri"/>
-              </a:rPr>
-              <a:t>167</a:t>
-            </a:r>
+              <a:rPr lang="en-US" sz="1250" b="1" dirty="0">
+                <a:solidFill>
+                  <a:srgbClr val="0F2A4A"/>
+                </a:solidFill>
+                <a:latin typeface="Calibri"/>
+              </a:rPr>
+              <a:t>250</a:t>
+            </a:r>
+            <a:endParaRPr sz="1250" b="0" i="0" dirty="0">
+              <a:solidFill>
+                <a:srgbClr val="FF0000"/>
+              </a:solidFill>
+              <a:latin typeface="Calibri"/>
+            </a:endParaRPr>
           </a:p>
           <a:p>
             <a:pPr marL="0" indent="0" algn="l">
@@ -9955,7 +10634,7 @@
               </a:spcAft>
             </a:pPr>
             <a:r>
-              <a:rPr sz="1250" b="1">
+              <a:rPr sz="1250" b="1" dirty="0">
                 <a:solidFill>
                   <a:srgbClr val="1F7A8C"/>
                 </a:solidFill>
@@ -9964,7 +10643,7 @@
               <a:t>▪  </a:t>
             </a:r>
             <a:r>
-              <a:rPr sz="1250" b="1">
+              <a:rPr sz="1250" b="1" dirty="0">
                 <a:solidFill>
                   <a:srgbClr val="0F2A4A"/>
                 </a:solidFill>
@@ -9973,13 +10652,40 @@
               <a:t>Language split: </a:t>
             </a:r>
             <a:r>
-              <a:rPr sz="1250" b="0" i="0">
+              <a:rPr lang="en-US" sz="1250" dirty="0">
                 <a:solidFill>
                   <a:srgbClr val="1A1F2B"/>
                 </a:solidFill>
                 <a:latin typeface="Calibri"/>
               </a:rPr>
-              <a:t>84 Python  /  83 C++</a:t>
+              <a:t>125</a:t>
+            </a:r>
+            <a:r>
+              <a:rPr sz="1250" b="0" i="0" dirty="0">
+                <a:solidFill>
+                  <a:srgbClr val="1A1F2B"/>
+                </a:solidFill>
+                <a:latin typeface="Calibri"/>
+              </a:rPr>
+              <a:t> Python  /  </a:t>
+            </a:r>
+            <a:r>
+              <a:rPr lang="en-US" sz="1250" b="0" i="0" dirty="0">
+                <a:solidFill>
+                  <a:srgbClr val="1A1F2B"/>
+                </a:solidFill>
+                <a:latin typeface="Calibri"/>
+              </a:rPr>
+              <a:t>125</a:t>
+            </a:r>
+            <a:r>
+              <a:rPr sz="1250" b="0" i="0" dirty="0">
+                <a:solidFill>
+                  <a:srgbClr val="1A1F2B"/>
+                </a:solidFill>
+                <a:latin typeface="Calibri"/>
+              </a:rPr>
+              <a:t> C++</a:t>
             </a:r>
           </a:p>
           <a:p>
@@ -9992,7 +10698,7 @@
               </a:spcAft>
             </a:pPr>
             <a:r>
-              <a:rPr sz="1250" b="1">
+              <a:rPr sz="1250" b="1" dirty="0">
                 <a:solidFill>
                   <a:srgbClr val="1F7A8C"/>
                 </a:solidFill>
@@ -10001,7 +10707,7 @@
               <a:t>▪  </a:t>
             </a:r>
             <a:r>
-              <a:rPr sz="1250" b="0" i="0">
+              <a:rPr sz="1250" b="0" i="0" dirty="0">
                 <a:solidFill>
                   <a:srgbClr val="1A1F2B"/>
                 </a:solidFill>
@@ -10300,7 +11006,7 @@
           <p:nvPr>
             <p:extLst>
               <p:ext uri="{D42A27DB-BD31-4B8C-83A1-F6EECF244321}">
-                <p14:modId xmlns:p14="http://schemas.microsoft.com/office/powerpoint/2010/main" val="4208741260"/>
+                <p14:modId xmlns:p14="http://schemas.microsoft.com/office/powerpoint/2010/main" val="1210112899"/>
               </p:ext>
             </p:extLst>
           </p:nvPr>
@@ -10516,13 +11222,40 @@
                     <a:lstStyle/>
                     <a:p>
                       <a:r>
-                        <a:rPr sz="1250">
+                        <a:rPr sz="1250" dirty="0" err="1">
                           <a:solidFill>
                             <a:srgbClr val="1A1F2B"/>
                           </a:solidFill>
                           <a:latin typeface="Calibri"/>
                         </a:rPr>
-                        <a:t>LoRA  (r=16, α=32)  +  4-bit NF4 quantization</a:t>
+                        <a:t>LoRA</a:t>
+                      </a:r>
+                      <a:r>
+                        <a:rPr sz="1250" dirty="0">
+                          <a:solidFill>
+                            <a:srgbClr val="1A1F2B"/>
+                          </a:solidFill>
+                          <a:latin typeface="Calibri"/>
+                        </a:rPr>
+                        <a:t>  (r=16, α=32</a:t>
+                      </a:r>
+                      <a:r>
+                        <a:rPr lang="en-US" sz="1250" dirty="0">
+                          <a:solidFill>
+                            <a:srgbClr val="1A1F2B"/>
+                          </a:solidFill>
+                          <a:latin typeface="Calibri"/>
+                        </a:rPr>
+                        <a:t>, dropout=0.1</a:t>
+                      </a:r>
+                      <a:r>
+                        <a:rPr sz="1250" dirty="0">
+                          <a:solidFill>
+                            <a:srgbClr val="1A1F2B"/>
+                          </a:solidFill>
+                          <a:latin typeface="Calibri"/>
+                        </a:rPr>
+                        <a:t>)</a:t>
                       </a:r>
                     </a:p>
                   </a:txBody>
@@ -10574,22 +11307,22 @@
                         <a:t>, </a:t>
                       </a:r>
                       <a:r>
-                        <a:rPr sz="1250" dirty="0" err="1">
+                        <a:rPr lang="en-US" sz="1250" dirty="0">
                           <a:solidFill>
                             <a:srgbClr val="1A1F2B"/>
                           </a:solidFill>
                           <a:latin typeface="Calibri"/>
                         </a:rPr>
-                        <a:t>Python→C</a:t>
+                        <a:t>C++ -&gt; </a:t>
                       </a:r>
                       <a:r>
                         <a:rPr sz="1250" dirty="0">
                           <a:solidFill>
-                            <a:srgbClr val="1A1F2B"/>
+                            <a:srgbClr val="002060"/>
                           </a:solidFill>
                           <a:latin typeface="Calibri"/>
                         </a:rPr>
-                        <a:t>++</a:t>
+                        <a:t>Python</a:t>
                       </a:r>
                     </a:p>
                   </a:txBody>
@@ -10634,18 +11367,45 @@
                     <a:lstStyle/>
                     <a:p>
                       <a:r>
-                        <a:rPr sz="1250">
+                        <a:rPr sz="1250" dirty="0" err="1">
                           <a:solidFill>
                             <a:srgbClr val="1A1F2B"/>
                           </a:solidFill>
                           <a:latin typeface="Calibri"/>
                         </a:rPr>
-                        <a:t>microsoft/graphcodebert-base</a:t>
+                        <a:t>microsoft</a:t>
+                      </a:r>
+                      <a:r>
+                        <a:rPr sz="1250" dirty="0">
+                          <a:solidFill>
+                            <a:srgbClr val="1A1F2B"/>
+                          </a:solidFill>
+                          <a:latin typeface="Calibri"/>
+                        </a:rPr>
+                        <a:t>/</a:t>
+                      </a:r>
+                      <a:r>
+                        <a:rPr sz="1250" dirty="0" err="1">
+                          <a:solidFill>
+                            <a:srgbClr val="1A1F2B"/>
+                          </a:solidFill>
+                          <a:latin typeface="Calibri"/>
+                        </a:rPr>
+                        <a:t>graphcodebert</a:t>
+                      </a:r>
+                      <a:r>
+                        <a:rPr sz="1250" dirty="0">
+                          <a:solidFill>
+                            <a:srgbClr val="1A1F2B"/>
+                          </a:solidFill>
+                          <a:latin typeface="Calibri"/>
+                        </a:rPr>
+                        <a:t>-base</a:t>
                       </a:r>
                     </a:p>
                     <a:p>
                       <a:r>
-                        <a:rPr sz="1250">
+                        <a:rPr sz="1250" dirty="0">
                           <a:solidFill>
                             <a:srgbClr val="1A1F2B"/>
                           </a:solidFill>
@@ -10887,7 +11647,7 @@
         <p:spPr>
           <a:xfrm>
             <a:off x="502920" y="4709160"/>
-            <a:ext cx="11155680" cy="1737360"/>
+            <a:ext cx="5928360" cy="1491690"/>
           </a:xfrm>
           <a:prstGeom prst="rect">
             <a:avLst/>
@@ -10909,7 +11669,7 @@
               </a:spcAft>
             </a:pPr>
             <a:r>
-              <a:rPr sz="1300" b="1">
+              <a:rPr sz="1300" b="1" dirty="0">
                 <a:solidFill>
                   <a:srgbClr val="1F7A8C"/>
                 </a:solidFill>
@@ -10918,7 +11678,7 @@
               <a:t>▪  </a:t>
             </a:r>
             <a:r>
-              <a:rPr sz="1300" b="1">
+              <a:rPr sz="1300" b="1" dirty="0" err="1">
                 <a:solidFill>
                   <a:srgbClr val="0F2A4A"/>
                 </a:solidFill>
@@ -10927,7 +11687,16 @@
               <a:t>PeftModel</a:t>
             </a:r>
             <a:r>
-              <a:rPr sz="1300" b="0" i="0">
+              <a:rPr lang="en-US" sz="1300" b="1" dirty="0">
+                <a:solidFill>
+                  <a:srgbClr val="0F2A4A"/>
+                </a:solidFill>
+                <a:latin typeface="Calibri"/>
+              </a:rPr>
+              <a:t> </a:t>
+            </a:r>
+            <a:r>
+              <a:rPr sz="1300" b="0" i="0" dirty="0">
                 <a:solidFill>
                   <a:srgbClr val="1A1F2B"/>
                 </a:solidFill>
@@ -10946,7 +11715,7 @@
               </a:spcAft>
             </a:pPr>
             <a:r>
-              <a:rPr sz="1300" b="1">
+              <a:rPr sz="1300" b="1" dirty="0">
                 <a:solidFill>
                   <a:srgbClr val="1F7A8C"/>
                 </a:solidFill>
@@ -10955,13 +11724,58 @@
               <a:t>▪  </a:t>
             </a:r>
             <a:r>
-              <a:rPr sz="1300" b="0" i="0">
+              <a:rPr sz="1300" b="1" dirty="0">
+                <a:solidFill>
+                  <a:srgbClr val="0F2A4A"/>
+                </a:solidFill>
+                <a:latin typeface="Calibri"/>
+              </a:rPr>
+              <a:t>Qwen model scores </a:t>
+            </a:r>
+            <a:r>
+              <a:rPr lang="en-US" sz="1300" b="1" dirty="0">
+                <a:solidFill>
+                  <a:srgbClr val="0F2A4A"/>
+                </a:solidFill>
+                <a:latin typeface="Calibri"/>
+              </a:rPr>
+              <a:t>documentation for </a:t>
+            </a:r>
+            <a:r>
+              <a:rPr sz="1300" b="1" dirty="0">
+                <a:solidFill>
+                  <a:srgbClr val="0F2A4A"/>
+                </a:solidFill>
+                <a:latin typeface="Calibri"/>
+              </a:rPr>
+              <a:t>generated C++ code 0–1 </a:t>
+            </a:r>
+            <a:r>
+              <a:rPr sz="1300" b="0" i="0" dirty="0">
                 <a:solidFill>
                   <a:srgbClr val="1A1F2B"/>
                 </a:solidFill>
                 <a:latin typeface="Calibri"/>
               </a:rPr>
-              <a:t> — hot-swapped at inference time</a:t>
+              <a:t>LLM-as-judge</a:t>
+            </a:r>
+            <a:r>
+              <a:rPr sz="1300" b="1" dirty="0">
+                <a:solidFill>
+                  <a:srgbClr val="1F7A8C"/>
+                </a:solidFill>
+                <a:latin typeface="Calibri"/>
+              </a:rPr>
+              <a:t> </a:t>
+            </a:r>
+            <a:r>
+              <a:rPr sz="1300" b="0" i="0" dirty="0">
+                <a:solidFill>
+                  <a:srgbClr val="1A1F2B"/>
+                </a:solidFill>
+                <a:latin typeface="Calibri"/>
+              </a:rPr>
+              <a:t>against documentation + reference before it is accepted for back-translation (quality threshold = 0.3)</a:t>
             </a:r>
           </a:p>
           <a:p>
@@ -10974,7 +11788,7 @@
               </a:spcAft>
             </a:pPr>
             <a:r>
-              <a:rPr sz="1300" b="1">
+              <a:rPr sz="1300" b="1" dirty="0">
                 <a:solidFill>
                   <a:srgbClr val="1F7A8C"/>
                 </a:solidFill>
@@ -10983,82 +11797,387 @@
               <a:t>▪  </a:t>
             </a:r>
             <a:r>
-              <a:rPr sz="1300" b="1">
-                <a:solidFill>
-                  <a:srgbClr val="0F2A4A"/>
-                </a:solidFill>
-                <a:latin typeface="Calibri"/>
-              </a:rPr>
-              <a:t>Qwen model scores generated C++ code 0–1 </a:t>
-            </a:r>
-            <a:r>
-              <a:rPr sz="1300" b="0" i="0">
+              <a:rPr sz="1300" b="0" i="0" dirty="0">
                 <a:solidFill>
                   <a:srgbClr val="1A1F2B"/>
                 </a:solidFill>
                 <a:latin typeface="Calibri"/>
               </a:rPr>
-              <a:t>LLM-as-judge: </a:t>
-            </a:r>
-          </a:p>
-          <a:p>
-            <a:pPr marL="0" indent="0" algn="l">
-              <a:lnSpc>
-                <a:spcPct val="108000"/>
-              </a:lnSpc>
-              <a:spcAft>
-                <a:spcPts val="800"/>
-              </a:spcAft>
-            </a:pPr>
-            <a:r>
-              <a:rPr sz="1300" b="1">
-                <a:solidFill>
-                  <a:srgbClr val="1F7A8C"/>
-                </a:solidFill>
-                <a:latin typeface="Calibri"/>
-              </a:rPr>
-              <a:t>▪  </a:t>
-            </a:r>
-            <a:r>
-              <a:rPr sz="1300" b="0" i="0">
+              <a:t>Tokenizer is shared from the base model — not bundled inside each </a:t>
+            </a:r>
+            <a:r>
+              <a:rPr sz="1300" b="0" i="0" dirty="0" err="1">
                 <a:solidFill>
                   <a:srgbClr val="1A1F2B"/>
                 </a:solidFill>
                 <a:latin typeface="Calibri"/>
               </a:rPr>
-              <a:t>against documentation + reference before it is accepted for back-translation (quality threshold = 0.3)</a:t>
-            </a:r>
-          </a:p>
-          <a:p>
-            <a:pPr marL="0" indent="0" algn="l">
-              <a:lnSpc>
-                <a:spcPct val="108000"/>
-              </a:lnSpc>
-              <a:spcAft>
-                <a:spcPts val="800"/>
-              </a:spcAft>
-            </a:pPr>
-            <a:r>
-              <a:rPr sz="1300" b="1">
-                <a:solidFill>
-                  <a:srgbClr val="1F7A8C"/>
-                </a:solidFill>
-                <a:latin typeface="Calibri"/>
-              </a:rPr>
-              <a:t>▪  </a:t>
-            </a:r>
-            <a:r>
-              <a:rPr sz="1300" b="0" i="0">
+              <a:t>LoRA</a:t>
+            </a:r>
+            <a:r>
+              <a:rPr sz="1300" b="0" i="0" dirty="0">
                 <a:solidFill>
                   <a:srgbClr val="1A1F2B"/>
                 </a:solidFill>
                 <a:latin typeface="Calibri"/>
               </a:rPr>
-              <a:t>Tokenizer is shared from the base model — not bundled inside each LoRA adapter</a:t>
-            </a:r>
-          </a:p>
-        </p:txBody>
-      </p:sp>
+              <a:t> adapter</a:t>
+            </a:r>
+          </a:p>
+        </p:txBody>
+      </p:sp>
+      <p:graphicFrame>
+        <p:nvGraphicFramePr>
+          <p:cNvPr id="11" name="Table 10">
+            <a:extLst>
+              <a:ext uri="{FF2B5EF4-FFF2-40B4-BE49-F238E27FC236}">
+                <a16:creationId xmlns:a16="http://schemas.microsoft.com/office/drawing/2014/main" id="{991B6900-837A-3412-A818-A44345E5C0B9}"/>
+              </a:ext>
+            </a:extLst>
+          </p:cNvPr>
+          <p:cNvGraphicFramePr>
+            <a:graphicFrameLocks noGrp="1"/>
+          </p:cNvGraphicFramePr>
+          <p:nvPr>
+            <p:extLst>
+              <p:ext uri="{D42A27DB-BD31-4B8C-83A1-F6EECF244321}">
+                <p14:modId xmlns:p14="http://schemas.microsoft.com/office/powerpoint/2010/main" val="2467856635"/>
+              </p:ext>
+            </p:extLst>
+          </p:nvPr>
+        </p:nvGraphicFramePr>
+        <p:xfrm>
+          <a:off x="7299960" y="4220565"/>
+          <a:ext cx="4358640" cy="2468880"/>
+        </p:xfrm>
+        <a:graphic>
+          <a:graphicData uri="http://schemas.openxmlformats.org/drawingml/2006/table">
+            <a:tbl>
+              <a:tblPr firstRow="1" bandRow="1">
+                <a:tableStyleId>{5C22544A-7EE6-4342-B048-85BDC9FD1C3A}</a:tableStyleId>
+              </a:tblPr>
+              <a:tblGrid>
+                <a:gridCol w="2346960">
+                  <a:extLst>
+                    <a:ext uri="{9D8B030D-6E8A-4147-A177-3AD203B41FA5}">
+                      <a16:colId xmlns:a16="http://schemas.microsoft.com/office/drawing/2014/main" val="165989430"/>
+                    </a:ext>
+                  </a:extLst>
+                </a:gridCol>
+                <a:gridCol w="2011680">
+                  <a:extLst>
+                    <a:ext uri="{9D8B030D-6E8A-4147-A177-3AD203B41FA5}">
+                      <a16:colId xmlns:a16="http://schemas.microsoft.com/office/drawing/2014/main" val="397747323"/>
+                    </a:ext>
+                  </a:extLst>
+                </a:gridCol>
+              </a:tblGrid>
+              <a:tr h="254226">
+                <a:tc>
+                  <a:txBody>
+                    <a:bodyPr/>
+                    <a:lstStyle/>
+                    <a:p>
+                      <a:r>
+                        <a:rPr lang="en-US" sz="1200" dirty="0"/>
+                        <a:t>Training Arguments</a:t>
+                      </a:r>
+                    </a:p>
+                  </a:txBody>
+                  <a:tcPr/>
+                </a:tc>
+                <a:tc>
+                  <a:txBody>
+                    <a:bodyPr/>
+                    <a:lstStyle/>
+                    <a:p>
+                      <a:r>
+                        <a:rPr lang="en-US" sz="1200" dirty="0"/>
+                        <a:t>Value</a:t>
+                      </a:r>
+                    </a:p>
+                  </a:txBody>
+                  <a:tcPr/>
+                </a:tc>
+                <a:extLst>
+                  <a:ext uri="{0D108BD9-81ED-4DB2-BD59-A6C34878D82A}">
+                    <a16:rowId xmlns:a16="http://schemas.microsoft.com/office/drawing/2014/main" val="3936539619"/>
+                  </a:ext>
+                </a:extLst>
+              </a:tr>
+              <a:tr h="254226">
+                <a:tc>
+                  <a:txBody>
+                    <a:bodyPr/>
+                    <a:lstStyle/>
+                    <a:p>
+                      <a:r>
+                        <a:rPr lang="en-US" sz="1200" dirty="0"/>
+                        <a:t>Device batch size</a:t>
+                      </a:r>
+                    </a:p>
+                  </a:txBody>
+                  <a:tcPr/>
+                </a:tc>
+                <a:tc>
+                  <a:txBody>
+                    <a:bodyPr/>
+                    <a:lstStyle/>
+                    <a:p>
+                      <a:r>
+                        <a:rPr lang="en-US" sz="1200" dirty="0"/>
+                        <a:t>1</a:t>
+                      </a:r>
+                    </a:p>
+                  </a:txBody>
+                  <a:tcPr/>
+                </a:tc>
+                <a:extLst>
+                  <a:ext uri="{0D108BD9-81ED-4DB2-BD59-A6C34878D82A}">
+                    <a16:rowId xmlns:a16="http://schemas.microsoft.com/office/drawing/2014/main" val="4261305299"/>
+                  </a:ext>
+                </a:extLst>
+              </a:tr>
+              <a:tr h="254226">
+                <a:tc>
+                  <a:txBody>
+                    <a:bodyPr/>
+                    <a:lstStyle/>
+                    <a:p>
+                      <a:r>
+                        <a:rPr lang="en-US" sz="1200" dirty="0"/>
+                        <a:t>Gradient accumulation steps</a:t>
+                      </a:r>
+                    </a:p>
+                  </a:txBody>
+                  <a:tcPr/>
+                </a:tc>
+                <a:tc>
+                  <a:txBody>
+                    <a:bodyPr/>
+                    <a:lstStyle/>
+                    <a:p>
+                      <a:r>
+                        <a:rPr lang="en-US" sz="1200" dirty="0"/>
+                        <a:t>8</a:t>
+                      </a:r>
+                    </a:p>
+                  </a:txBody>
+                  <a:tcPr/>
+                </a:tc>
+                <a:extLst>
+                  <a:ext uri="{0D108BD9-81ED-4DB2-BD59-A6C34878D82A}">
+                    <a16:rowId xmlns:a16="http://schemas.microsoft.com/office/drawing/2014/main" val="4118362070"/>
+                  </a:ext>
+                </a:extLst>
+              </a:tr>
+              <a:tr h="254226">
+                <a:tc>
+                  <a:txBody>
+                    <a:bodyPr/>
+                    <a:lstStyle/>
+                    <a:p>
+                      <a:r>
+                        <a:rPr lang="en-US" sz="1200" dirty="0"/>
+                        <a:t>Num train epochs</a:t>
+                      </a:r>
+                    </a:p>
+                  </a:txBody>
+                  <a:tcPr/>
+                </a:tc>
+                <a:tc>
+                  <a:txBody>
+                    <a:bodyPr/>
+                    <a:lstStyle/>
+                    <a:p>
+                      <a:r>
+                        <a:rPr lang="en-US" sz="1200" dirty="0"/>
+                        <a:t>3/30</a:t>
+                      </a:r>
+                    </a:p>
+                  </a:txBody>
+                  <a:tcPr/>
+                </a:tc>
+                <a:extLst>
+                  <a:ext uri="{0D108BD9-81ED-4DB2-BD59-A6C34878D82A}">
+                    <a16:rowId xmlns:a16="http://schemas.microsoft.com/office/drawing/2014/main" val="1893283960"/>
+                  </a:ext>
+                </a:extLst>
+              </a:tr>
+              <a:tr h="254226">
+                <a:tc>
+                  <a:txBody>
+                    <a:bodyPr/>
+                    <a:lstStyle/>
+                    <a:p>
+                      <a:r>
+                        <a:rPr lang="en-US" sz="1200" dirty="0"/>
+                        <a:t>Learning rate</a:t>
+                      </a:r>
+                    </a:p>
+                  </a:txBody>
+                  <a:tcPr/>
+                </a:tc>
+                <a:tc>
+                  <a:txBody>
+                    <a:bodyPr/>
+                    <a:lstStyle/>
+                    <a:p>
+                      <a:r>
+                        <a:rPr lang="en-US" sz="1200" dirty="0"/>
+                        <a:t>2e</a:t>
+                      </a:r>
+                      <a:r>
+                        <a:rPr lang="en-US" sz="1200" baseline="30000" dirty="0"/>
+                        <a:t>-4</a:t>
+                      </a:r>
+                      <a:endParaRPr lang="en-US" sz="1200" dirty="0"/>
+                    </a:p>
+                  </a:txBody>
+                  <a:tcPr/>
+                </a:tc>
+                <a:extLst>
+                  <a:ext uri="{0D108BD9-81ED-4DB2-BD59-A6C34878D82A}">
+                    <a16:rowId xmlns:a16="http://schemas.microsoft.com/office/drawing/2014/main" val="340540733"/>
+                  </a:ext>
+                </a:extLst>
+              </a:tr>
+              <a:tr h="254226">
+                <a:tc>
+                  <a:txBody>
+                    <a:bodyPr/>
+                    <a:lstStyle/>
+                    <a:p>
+                      <a:r>
+                        <a:rPr lang="en-US" sz="1200" dirty="0"/>
+                        <a:t>Logging steps</a:t>
+                      </a:r>
+                    </a:p>
+                  </a:txBody>
+                  <a:tcPr/>
+                </a:tc>
+                <a:tc>
+                  <a:txBody>
+                    <a:bodyPr/>
+                    <a:lstStyle/>
+                    <a:p>
+                      <a:r>
+                        <a:rPr lang="en-US" sz="1200" dirty="0"/>
+                        <a:t>10</a:t>
+                      </a:r>
+                    </a:p>
+                  </a:txBody>
+                  <a:tcPr/>
+                </a:tc>
+                <a:extLst>
+                  <a:ext uri="{0D108BD9-81ED-4DB2-BD59-A6C34878D82A}">
+                    <a16:rowId xmlns:a16="http://schemas.microsoft.com/office/drawing/2014/main" val="3572586060"/>
+                  </a:ext>
+                </a:extLst>
+              </a:tr>
+              <a:tr h="254226">
+                <a:tc>
+                  <a:txBody>
+                    <a:bodyPr/>
+                    <a:lstStyle/>
+                    <a:p>
+                      <a:r>
+                        <a:rPr lang="en-US" sz="1200" dirty="0"/>
+                        <a:t>Save strategy</a:t>
+                      </a:r>
+                    </a:p>
+                  </a:txBody>
+                  <a:tcPr/>
+                </a:tc>
+                <a:tc>
+                  <a:txBody>
+                    <a:bodyPr/>
+                    <a:lstStyle/>
+                    <a:p>
+                      <a:r>
+                        <a:rPr lang="en-US" sz="1200" dirty="0"/>
+                        <a:t>Epoch (save every epoch)</a:t>
+                      </a:r>
+                    </a:p>
+                  </a:txBody>
+                  <a:tcPr/>
+                </a:tc>
+                <a:extLst>
+                  <a:ext uri="{0D108BD9-81ED-4DB2-BD59-A6C34878D82A}">
+                    <a16:rowId xmlns:a16="http://schemas.microsoft.com/office/drawing/2014/main" val="274416401"/>
+                  </a:ext>
+                </a:extLst>
+              </a:tr>
+              <a:tr h="254226">
+                <a:tc>
+                  <a:txBody>
+                    <a:bodyPr/>
+                    <a:lstStyle/>
+                    <a:p>
+                      <a:r>
+                        <a:rPr lang="en-US" sz="1200" dirty="0"/>
+                        <a:t>Save total limit</a:t>
+                      </a:r>
+                    </a:p>
+                  </a:txBody>
+                  <a:tcPr/>
+                </a:tc>
+                <a:tc>
+                  <a:txBody>
+                    <a:bodyPr/>
+                    <a:lstStyle/>
+                    <a:p>
+                      <a:r>
+                        <a:rPr lang="en-US" sz="1200" dirty="0"/>
+                        <a:t>1 (save the best)</a:t>
+                      </a:r>
+                    </a:p>
+                  </a:txBody>
+                  <a:tcPr/>
+                </a:tc>
+                <a:extLst>
+                  <a:ext uri="{0D108BD9-81ED-4DB2-BD59-A6C34878D82A}">
+                    <a16:rowId xmlns:a16="http://schemas.microsoft.com/office/drawing/2014/main" val="573669485"/>
+                  </a:ext>
+                </a:extLst>
+              </a:tr>
+              <a:tr h="254226">
+                <a:tc>
+                  <a:txBody>
+                    <a:bodyPr/>
+                    <a:lstStyle/>
+                    <a:p>
+                      <a:r>
+                        <a:rPr lang="en-US" sz="1200" dirty="0"/>
+                        <a:t>Fp16</a:t>
+                      </a:r>
+                    </a:p>
+                  </a:txBody>
+                  <a:tcPr/>
+                </a:tc>
+                <a:tc>
+                  <a:txBody>
+                    <a:bodyPr/>
+                    <a:lstStyle/>
+                    <a:p>
+                      <a:r>
+                        <a:rPr lang="en-US" sz="1200" dirty="0"/>
+                        <a:t>True (save memory)</a:t>
+                      </a:r>
+                    </a:p>
+                  </a:txBody>
+                  <a:tcPr/>
+                </a:tc>
+                <a:extLst>
+                  <a:ext uri="{0D108BD9-81ED-4DB2-BD59-A6C34878D82A}">
+                    <a16:rowId xmlns:a16="http://schemas.microsoft.com/office/drawing/2014/main" val="161452878"/>
+                  </a:ext>
+                </a:extLst>
+              </a:tr>
+            </a:tbl>
+          </a:graphicData>
+        </a:graphic>
+      </p:graphicFrame>
     </p:spTree>
   </p:cSld>
   <p:clrMapOvr>
@@ -11895,7 +13014,7 @@
         <p:spPr>
           <a:xfrm>
             <a:off x="502920" y="3154680"/>
-            <a:ext cx="5486400" cy="2194560"/>
+            <a:ext cx="5486400" cy="1162113"/>
           </a:xfrm>
           <a:prstGeom prst="rect">
             <a:avLst/>
@@ -11917,7 +13036,7 @@
               </a:spcAft>
             </a:pPr>
             <a:r>
-              <a:rPr sz="1300" b="1">
+              <a:rPr sz="1300" b="1" dirty="0">
                 <a:solidFill>
                   <a:srgbClr val="1F7A8C"/>
                 </a:solidFill>
@@ -11926,7 +13045,7 @@
               <a:t>▪  </a:t>
             </a:r>
             <a:r>
-              <a:rPr sz="1300" b="0" i="0">
+              <a:rPr sz="1300" b="0" i="0" dirty="0">
                 <a:solidFill>
                   <a:srgbClr val="1A1F2B"/>
                 </a:solidFill>
@@ -11945,7 +13064,7 @@
               </a:spcAft>
             </a:pPr>
             <a:r>
-              <a:rPr sz="1300" b="1">
+              <a:rPr sz="1300" b="1" dirty="0">
                 <a:solidFill>
                   <a:srgbClr val="1F7A8C"/>
                 </a:solidFill>
@@ -11954,13 +13073,76 @@
               <a:t>▪  </a:t>
             </a:r>
             <a:r>
-              <a:rPr sz="1300" b="0" i="0">
+              <a:rPr lang="en-US" sz="1300" dirty="0">
+                <a:solidFill>
+                  <a:srgbClr val="002060"/>
+                </a:solidFill>
+                <a:latin typeface="Calibri"/>
+              </a:rPr>
+              <a:t>C++ -&gt; P</a:t>
+            </a:r>
+            <a:r>
+              <a:rPr sz="1300" b="0" i="0" dirty="0">
+                <a:solidFill>
+                  <a:srgbClr val="002060"/>
+                </a:solidFill>
+                <a:latin typeface="Calibri"/>
+              </a:rPr>
+              <a:t>ython</a:t>
+            </a:r>
+            <a:r>
+              <a:rPr sz="1300" b="0" i="0" dirty="0">
                 <a:solidFill>
                   <a:srgbClr val="1A1F2B"/>
                 </a:solidFill>
                 <a:latin typeface="Calibri"/>
               </a:rPr>
-              <a:t>Python → C++ — paste Python, get an equivalent C++ implementation</a:t>
+              <a:t>— paste </a:t>
+            </a:r>
+            <a:r>
+              <a:rPr lang="en-US" sz="1300" b="0" i="0" dirty="0">
+                <a:solidFill>
+                  <a:srgbClr val="1A1F2B"/>
+                </a:solidFill>
+                <a:latin typeface="Calibri"/>
+              </a:rPr>
+              <a:t>C++</a:t>
+            </a:r>
+            <a:r>
+              <a:rPr lang="en-US" sz="1300" dirty="0">
+                <a:solidFill>
+                  <a:srgbClr val="1A1F2B"/>
+                </a:solidFill>
+                <a:latin typeface="Calibri"/>
+              </a:rPr>
+              <a:t> and</a:t>
+            </a:r>
+            <a:r>
+              <a:rPr sz="1300" b="0" i="0" dirty="0">
+                <a:solidFill>
+                  <a:srgbClr val="1A1F2B"/>
+                </a:solidFill>
+                <a:latin typeface="Calibri"/>
+              </a:rPr>
+              <a:t> get an equivalent </a:t>
+            </a:r>
+            <a:r>
+              <a:rPr lang="en-US" sz="1300" b="0" i="0" dirty="0">
+                <a:solidFill>
+                  <a:srgbClr val="1A1F2B"/>
+                </a:solidFill>
+                <a:latin typeface="Calibri"/>
+              </a:rPr>
+              <a:t>Python</a:t>
+            </a:r>
+            <a:r>
+              <a:rPr sz="1300" b="0" i="0" dirty="0">
+                <a:solidFill>
+                  <a:srgbClr val="1A1F2B"/>
+                </a:solidFill>
+                <a:latin typeface="Calibri"/>
+              </a:rPr>
+              <a:t> implementation</a:t>
             </a:r>
           </a:p>
           <a:p>
@@ -11973,7 +13155,7 @@
               </a:spcAft>
             </a:pPr>
             <a:r>
-              <a:rPr sz="1300" b="1">
+              <a:rPr sz="1300" b="1" dirty="0">
                 <a:solidFill>
                   <a:srgbClr val="1F7A8C"/>
                 </a:solidFill>
@@ -11982,7 +13164,7 @@
               <a:t>▪  </a:t>
             </a:r>
             <a:r>
-              <a:rPr sz="1300" b="0" i="0">
+              <a:rPr sz="1300" b="0" i="0" dirty="0">
                 <a:solidFill>
                   <a:srgbClr val="1A1F2B"/>
                 </a:solidFill>
@@ -12001,7 +13183,7 @@
               </a:spcAft>
             </a:pPr>
             <a:r>
-              <a:rPr sz="1300" b="1">
+              <a:rPr sz="1300" b="1" dirty="0">
                 <a:solidFill>
                   <a:srgbClr val="1F7A8C"/>
                 </a:solidFill>
@@ -12010,7 +13192,7 @@
               <a:t>▪  </a:t>
             </a:r>
             <a:r>
-              <a:rPr sz="1300" b="0" i="0">
+              <a:rPr sz="1300" b="0" i="0" dirty="0">
                 <a:solidFill>
                   <a:srgbClr val="1A1F2B"/>
                 </a:solidFill>
@@ -12069,7 +13251,7 @@
         <p:spPr>
           <a:xfrm>
             <a:off x="6400800" y="3154680"/>
-            <a:ext cx="5257800" cy="2194560"/>
+            <a:ext cx="5257800" cy="1162113"/>
           </a:xfrm>
           <a:prstGeom prst="rect">
             <a:avLst/>
@@ -12091,7 +13273,7 @@
               </a:spcAft>
             </a:pPr>
             <a:r>
-              <a:rPr sz="1300" b="1">
+              <a:rPr sz="1300" b="1" dirty="0">
                 <a:solidFill>
                   <a:srgbClr val="1F7A8C"/>
                 </a:solidFill>
@@ -12100,7 +13282,7 @@
               <a:t>▪  </a:t>
             </a:r>
             <a:r>
-              <a:rPr sz="1300" b="1">
+              <a:rPr sz="1300" b="1" dirty="0" err="1">
                 <a:solidFill>
                   <a:srgbClr val="0F2A4A"/>
                 </a:solidFill>
@@ -12109,13 +13291,22 @@
               <a:t>Gradio</a:t>
             </a:r>
             <a:r>
-              <a:rPr sz="1300" b="0" i="0">
+              <a:rPr lang="en-US" sz="1300" b="1" dirty="0">
+                <a:solidFill>
+                  <a:srgbClr val="0F2A4A"/>
+                </a:solidFill>
+                <a:latin typeface="Calibri"/>
+              </a:rPr>
+              <a:t> </a:t>
+            </a:r>
+            <a:r>
+              <a:rPr sz="1300" b="0" i="0" dirty="0">
                 <a:solidFill>
                   <a:srgbClr val="1A1F2B"/>
                 </a:solidFill>
                 <a:latin typeface="Calibri"/>
               </a:rPr>
-              <a:t>Built with </a:t>
+              <a:t>Built with shareable public web URL</a:t>
             </a:r>
           </a:p>
           <a:p>
@@ -12128,7 +13319,7 @@
               </a:spcAft>
             </a:pPr>
             <a:r>
-              <a:rPr sz="1300" b="1">
+              <a:rPr sz="1300" b="1" dirty="0">
                 <a:solidFill>
                   <a:srgbClr val="1F7A8C"/>
                 </a:solidFill>
@@ -12137,13 +13328,31 @@
               <a:t>▪  </a:t>
             </a:r>
             <a:r>
-              <a:rPr sz="1300" b="0" i="0">
+              <a:rPr sz="1300" b="0" i="0" dirty="0">
                 <a:solidFill>
                   <a:srgbClr val="1A1F2B"/>
                 </a:solidFill>
                 <a:latin typeface="Calibri"/>
               </a:rPr>
-              <a:t> — shareable public web URL</a:t>
+              <a:t>Runs on Google </a:t>
+            </a:r>
+            <a:r>
+              <a:rPr sz="1300" b="0" i="0" dirty="0" err="1">
+                <a:solidFill>
+                  <a:srgbClr val="1A1F2B"/>
+                </a:solidFill>
+                <a:latin typeface="Calibri"/>
+              </a:rPr>
+              <a:t>Colab</a:t>
+            </a:r>
+            <a:r>
+              <a:rPr sz="1300" b="0" i="0" dirty="0">
+                <a:solidFill>
+                  <a:srgbClr val="1A1F2B"/>
+                </a:solidFill>
+                <a:latin typeface="Calibri"/>
+              </a:rPr>
+              <a:t> with T4 / L4 GPU acceleration</a:t>
             </a:r>
           </a:p>
           <a:p>
@@ -12156,7 +13365,7 @@
               </a:spcAft>
             </a:pPr>
             <a:r>
-              <a:rPr sz="1300" b="1">
+              <a:rPr sz="1300" b="1" dirty="0">
                 <a:solidFill>
                   <a:srgbClr val="1F7A8C"/>
                 </a:solidFill>
@@ -12165,13 +13374,13 @@
               <a:t>▪  </a:t>
             </a:r>
             <a:r>
-              <a:rPr sz="1300" b="0" i="0">
+              <a:rPr sz="1300" b="0" i="0" dirty="0">
                 <a:solidFill>
                   <a:srgbClr val="1A1F2B"/>
                 </a:solidFill>
                 <a:latin typeface="Calibri"/>
               </a:rPr>
-              <a:t>Runs on Google Colab with T4 / L4 GPU acceleration</a:t>
+              <a:t>Adapters + base model downloaded and 4-bit quantized at startup</a:t>
             </a:r>
           </a:p>
           <a:p>
@@ -12184,7 +13393,7 @@
               </a:spcAft>
             </a:pPr>
             <a:r>
-              <a:rPr sz="1300" b="1">
+              <a:rPr sz="1300" b="1" dirty="0">
                 <a:solidFill>
                   <a:srgbClr val="1F7A8C"/>
                 </a:solidFill>
@@ -12193,35 +13402,7 @@
               <a:t>▪  </a:t>
             </a:r>
             <a:r>
-              <a:rPr sz="1300" b="0" i="0">
-                <a:solidFill>
-                  <a:srgbClr val="1A1F2B"/>
-                </a:solidFill>
-                <a:latin typeface="Calibri"/>
-              </a:rPr>
-              <a:t>Adapters + base model downloaded and 4-bit quantized at startup</a:t>
-            </a:r>
-          </a:p>
-          <a:p>
-            <a:pPr marL="0" indent="0" algn="l">
-              <a:lnSpc>
-                <a:spcPct val="108000"/>
-              </a:lnSpc>
-              <a:spcAft>
-                <a:spcPts val="800"/>
-              </a:spcAft>
-            </a:pPr>
-            <a:r>
-              <a:rPr sz="1300" b="1">
-                <a:solidFill>
-                  <a:srgbClr val="1F7A8C"/>
-                </a:solidFill>
-                <a:latin typeface="Calibri"/>
-              </a:rPr>
-              <a:t>▪  </a:t>
-            </a:r>
-            <a:r>
-              <a:rPr sz="1300" b="0" i="0">
+              <a:rPr sz="1300" b="0" i="0" dirty="0">
                 <a:solidFill>
                   <a:srgbClr val="1A1F2B"/>
                 </a:solidFill>
@@ -12972,8 +14153,8 @@
         </p:nvSpPr>
         <p:spPr>
           <a:xfrm>
-            <a:off x="3657600" y="4059936"/>
-            <a:ext cx="8046720" cy="777240"/>
+            <a:off x="3657600" y="4242249"/>
+            <a:ext cx="8046720" cy="412613"/>
           </a:xfrm>
           <a:prstGeom prst="rect">
             <a:avLst/>
@@ -12992,13 +14173,31 @@
               </a:lnSpc>
             </a:pPr>
             <a:r>
-              <a:rPr sz="1250" b="0" i="0">
+              <a:rPr sz="1250" b="0" i="0" dirty="0">
                 <a:solidFill>
                   <a:srgbClr val="1A1F2B"/>
                 </a:solidFill>
                 <a:latin typeface="Calibri"/>
               </a:rPr>
-              <a:t>Qwen2.5-Coder scores generated C++ (0–1) against documentation + reference before it is accepted for Python back-translation; quality threshold = 0.3</a:t>
+              <a:t>Qwen2.5-Coder scores generated </a:t>
+            </a:r>
+            <a:r>
+              <a:rPr lang="en-US" sz="1250" b="0" i="0" dirty="0">
+                <a:solidFill>
+                  <a:srgbClr val="1A1F2B"/>
+                </a:solidFill>
+                <a:latin typeface="Calibri"/>
+              </a:rPr>
+              <a:t>Python</a:t>
+            </a:r>
+            <a:r>
+              <a:rPr sz="1250" b="0" i="0" dirty="0">
+                <a:solidFill>
+                  <a:srgbClr val="1A1F2B"/>
+                </a:solidFill>
+                <a:latin typeface="Calibri"/>
+              </a:rPr>
+              <a:t> (0–1) against documentation + reference before it is accepted for Python back-translation</a:t>
             </a:r>
           </a:p>
         </p:txBody>
@@ -13096,7 +14295,7 @@
         <p:spPr>
           <a:xfrm>
             <a:off x="502920" y="5641848"/>
-            <a:ext cx="11155680" cy="822960"/>
+            <a:ext cx="11155680" cy="508473"/>
           </a:xfrm>
           <a:prstGeom prst="rect">
             <a:avLst/>
@@ -13118,7 +14317,7 @@
               </a:spcAft>
             </a:pPr>
             <a:r>
-              <a:rPr sz="1250" b="1">
+              <a:rPr sz="1250" b="1" dirty="0">
                 <a:solidFill>
                   <a:srgbClr val="1F7A8C"/>
                 </a:solidFill>
@@ -13127,7 +14326,7 @@
               <a:t>▪  </a:t>
             </a:r>
             <a:r>
-              <a:rPr sz="1250" b="1">
+              <a:rPr sz="1250" b="1" dirty="0">
                 <a:solidFill>
                   <a:srgbClr val="0F2A4A"/>
                 </a:solidFill>
@@ -13136,13 +14335,22 @@
               <a:t>3 times</a:t>
             </a:r>
             <a:r>
-              <a:rPr sz="1250" b="0" i="0">
+              <a:rPr lang="en-US" sz="1250" b="1" dirty="0">
+                <a:solidFill>
+                  <a:srgbClr val="0F2A4A"/>
+                </a:solidFill>
+                <a:latin typeface="Calibri"/>
+              </a:rPr>
+              <a:t> </a:t>
+            </a:r>
+            <a:r>
+              <a:rPr sz="1250" b="0" i="0" dirty="0">
                 <a:solidFill>
                   <a:srgbClr val="1A1F2B"/>
                 </a:solidFill>
                 <a:latin typeface="Calibri"/>
               </a:rPr>
-              <a:t>Each generation step (documentation, code, PL1→PL2) is repeated </a:t>
+              <a:t>Each generation step (documentation, code, PL1→PL2) is repeated; the highest-scoring attempt is retained per record</a:t>
             </a:r>
           </a:p>
           <a:p>
@@ -13155,7 +14363,7 @@
               </a:spcAft>
             </a:pPr>
             <a:r>
-              <a:rPr sz="1250" b="1">
+              <a:rPr sz="1250" b="1" dirty="0">
                 <a:solidFill>
                   <a:srgbClr val="1F7A8C"/>
                 </a:solidFill>
@@ -13164,41 +14372,58 @@
               <a:t>▪  </a:t>
             </a:r>
             <a:r>
-              <a:rPr sz="1250" b="0" i="0">
+              <a:rPr sz="1250" b="0" i="0" dirty="0" err="1">
                 <a:solidFill>
                   <a:srgbClr val="1A1F2B"/>
                 </a:solidFill>
                 <a:latin typeface="Calibri"/>
               </a:rPr>
-              <a:t>; the highest-scoring attempt is retained per record</a:t>
-            </a:r>
-          </a:p>
-          <a:p>
-            <a:pPr marL="0" indent="0" algn="l">
-              <a:lnSpc>
-                <a:spcPct val="108000"/>
-              </a:lnSpc>
-              <a:spcAft>
-                <a:spcPts val="800"/>
-              </a:spcAft>
-            </a:pPr>
-            <a:r>
-              <a:rPr sz="1250" b="1">
-                <a:solidFill>
-                  <a:srgbClr val="1F7A8C"/>
-                </a:solidFill>
-                <a:latin typeface="Calibri"/>
-              </a:rPr>
-              <a:t>▪  </a:t>
-            </a:r>
-            <a:r>
-              <a:rPr sz="1250" b="0" i="0">
+              <a:t>compute_summary</a:t>
+            </a:r>
+            <a:r>
+              <a:rPr sz="1250" b="0" i="0" dirty="0">
                 <a:solidFill>
                   <a:srgbClr val="1A1F2B"/>
                 </a:solidFill>
                 <a:latin typeface="Calibri"/>
               </a:rPr>
-              <a:t>compute_summary() aggregates results by language (Python / C++) and by phase (NL→PL, NL→PL1→PL2)</a:t>
+              <a:t>() aggregates results by language (Python / C++) and by phase (NL→PL</a:t>
+            </a:r>
+            <a:r>
+              <a:rPr lang="en-US" sz="1250" b="0" i="0" dirty="0">
+                <a:solidFill>
+                  <a:srgbClr val="1A1F2B"/>
+                </a:solidFill>
+                <a:latin typeface="Calibri"/>
+              </a:rPr>
+              <a:t>1/PL2 and</a:t>
+            </a:r>
+            <a:r>
+              <a:rPr sz="1250" b="0" i="0" dirty="0">
+                <a:solidFill>
+                  <a:srgbClr val="1A1F2B"/>
+                </a:solidFill>
+                <a:latin typeface="Calibri"/>
+              </a:rPr>
+              <a:t> </a:t>
+            </a:r>
+            <a:r>
+              <a:rPr lang="en-US" sz="1250" b="0" i="0" dirty="0">
+                <a:solidFill>
+                  <a:srgbClr val="1A1F2B"/>
+                </a:solidFill>
+                <a:latin typeface="Calibri"/>
+              </a:rPr>
+              <a:t>PL2-&gt;</a:t>
+            </a:r>
+            <a:r>
+              <a:rPr sz="1250" b="0" i="0" dirty="0">
+                <a:solidFill>
+                  <a:srgbClr val="1A1F2B"/>
+                </a:solidFill>
+                <a:latin typeface="Calibri"/>
+              </a:rPr>
+              <a:t>NL→PL1→PL2)</a:t>
             </a:r>
           </a:p>
         </p:txBody>
@@ -14739,6 +15964,53 @@
           </a:p>
         </p:txBody>
       </p:sp>
+      <p:sp>
+        <p:nvSpPr>
+          <p:cNvPr id="28" name="Rectangle 27">
+            <a:extLst>
+              <a:ext uri="{FF2B5EF4-FFF2-40B4-BE49-F238E27FC236}">
+                <a16:creationId xmlns:a16="http://schemas.microsoft.com/office/drawing/2014/main" id="{9EDA1A26-9C4F-6BD5-D115-FCC81CED3EDE}"/>
+              </a:ext>
+            </a:extLst>
+          </p:cNvPr>
+          <p:cNvSpPr/>
+          <p:nvPr/>
+        </p:nvSpPr>
+        <p:spPr>
+          <a:xfrm>
+            <a:off x="7818120" y="5133975"/>
+            <a:ext cx="3200400" cy="1228725"/>
+          </a:xfrm>
+          <a:prstGeom prst="rect">
+            <a:avLst/>
+          </a:prstGeom>
+        </p:spPr>
+        <p:style>
+          <a:lnRef idx="1">
+            <a:schemeClr val="accent1"/>
+          </a:lnRef>
+          <a:fillRef idx="3">
+            <a:schemeClr val="accent1"/>
+          </a:fillRef>
+          <a:effectRef idx="2">
+            <a:schemeClr val="accent1"/>
+          </a:effectRef>
+          <a:fontRef idx="minor">
+            <a:schemeClr val="lt1"/>
+          </a:fontRef>
+        </p:style>
+        <p:txBody>
+          <a:bodyPr rtlCol="0" anchor="ctr"/>
+          <a:lstStyle/>
+          <a:p>
+            <a:pPr algn="ctr"/>
+            <a:r>
+              <a:rPr lang="en-US" dirty="0"/>
+              <a:t>Updated?</a:t>
+            </a:r>
+          </a:p>
+        </p:txBody>
+      </p:sp>
     </p:spTree>
   </p:cSld>
   <p:clrMapOvr>
@@ -15024,7 +16296,13 @@
           <p:cNvGraphicFramePr>
             <a:graphicFrameLocks noGrp="1"/>
           </p:cNvGraphicFramePr>
-          <p:nvPr/>
+          <p:nvPr>
+            <p:extLst>
+              <p:ext uri="{D42A27DB-BD31-4B8C-83A1-F6EECF244321}">
+                <p14:modId xmlns:p14="http://schemas.microsoft.com/office/powerpoint/2010/main" val="1016713564"/>
+              </p:ext>
+            </p:extLst>
+          </p:nvPr>
         </p:nvGraphicFramePr>
         <p:xfrm>
           <a:off x="411480" y="1234440"/>
@@ -15266,7 +16544,7 @@
                         </a:lnSpc>
                       </a:pPr>
                       <a:r>
-                        <a:rPr sz="1030">
+                        <a:rPr sz="1030" dirty="0">
                           <a:solidFill>
                             <a:srgbClr val="1A1F2B"/>
                           </a:solidFill>
@@ -15274,6 +16552,39 @@
                         </a:rPr>
                         <a:t>Wrong model choice for NL→PL; switched to Qwen/Qwen2.5-Coder-7B-Instruct</a:t>
                       </a:r>
+                      <a:r>
+                        <a:rPr lang="en-US" sz="1030" dirty="0">
+                          <a:solidFill>
+                            <a:srgbClr val="1A1F2B"/>
+                          </a:solidFill>
+                          <a:latin typeface="+mn-lt"/>
+                        </a:rPr>
+                        <a:t>. Qwen/Qwen2.5-Coder-0.5B-Instruct had similar prompt </a:t>
+                      </a:r>
+                      <a:r>
+                        <a:rPr lang="en-US" sz="1030" dirty="0" err="1">
+                          <a:solidFill>
+                            <a:srgbClr val="1A1F2B"/>
+                          </a:solidFill>
+                          <a:latin typeface="+mn-lt"/>
+                        </a:rPr>
+                        <a:t>reptition</a:t>
+                      </a:r>
+                      <a:r>
+                        <a:rPr lang="en-US" sz="1030" dirty="0">
+                          <a:solidFill>
+                            <a:srgbClr val="1A1F2B"/>
+                          </a:solidFill>
+                          <a:latin typeface="+mn-lt"/>
+                        </a:rPr>
+                        <a:t> problem</a:t>
+                      </a:r>
+                      <a:endParaRPr sz="1030" dirty="0">
+                        <a:solidFill>
+                          <a:srgbClr val="1A1F2B"/>
+                        </a:solidFill>
+                        <a:latin typeface="Calibri"/>
+                      </a:endParaRPr>
                     </a:p>
                   </a:txBody>
                   <a:tcPr marT="38100" marB="38100" anchor="ctr">
@@ -15300,14 +16611,29 @@
                         </a:lnSpc>
                       </a:pPr>
                       <a:r>
-                        <a:rPr sz="1030">
+                        <a:rPr lang="en-US" sz="1030" dirty="0">
                           <a:solidFill>
                             <a:srgbClr val="1A1F2B"/>
                           </a:solidFill>
                           <a:latin typeface="Calibri"/>
                         </a:rPr>
-                        <a:t>codegen-350M-multi threw index-out-of-bounds errors; CUDA:1 tensors held garbage values — hooks, rope_scaling and token-limit fixes all failed</a:t>
+                        <a:t>Moved to  </a:t>
                       </a:r>
+                      <a:r>
+                        <a:rPr lang="en-US" sz="1030" dirty="0">
+                          <a:solidFill>
+                            <a:srgbClr val="1A1F2B"/>
+                          </a:solidFill>
+                          <a:latin typeface="+mn-lt"/>
+                        </a:rPr>
+                        <a:t>Qwen/Qwen2.5-Coder-0.5B-Instruct</a:t>
+                      </a:r>
+                      <a:endParaRPr sz="1030" dirty="0">
+                        <a:solidFill>
+                          <a:srgbClr val="1A1F2B"/>
+                        </a:solidFill>
+                        <a:latin typeface="Calibri"/>
+                      </a:endParaRPr>
                     </a:p>
                   </a:txBody>
                   <a:tcPr marT="38100" marB="38100" anchor="ctr">
@@ -15327,14 +16653,38 @@
                         </a:lnSpc>
                       </a:pPr>
                       <a:r>
-                        <a:rPr sz="1030">
+                        <a:rPr lang="en-US" sz="1030" dirty="0">
                           <a:solidFill>
                             <a:srgbClr val="1A1F2B"/>
                           </a:solidFill>
-                          <a:latin typeface="Calibri"/>
+                          <a:latin typeface="+mn-lt"/>
                         </a:rPr>
-                        <a:t>Pinned to a single GPU (CUDA_VISIBLE_DEVICES) with CUDA_LAUNCH_BLOCKING / TORCH_USE_CUDA_DSA for debugging</a:t>
+                        <a:t>Qwen/Qwen2.5-Coder-0.5B-Instruct had similar prompt </a:t>
                       </a:r>
+                      <a:r>
+                        <a:rPr lang="en-US" sz="1030" dirty="0" err="1">
+                          <a:solidFill>
+                            <a:srgbClr val="1A1F2B"/>
+                          </a:solidFill>
+                          <a:latin typeface="+mn-lt"/>
+                        </a:rPr>
+                        <a:t>reptition</a:t>
+                      </a:r>
+                      <a:r>
+                        <a:rPr lang="en-US" sz="1030" dirty="0">
+                          <a:solidFill>
+                            <a:srgbClr val="1A1F2B"/>
+                          </a:solidFill>
+                          <a:latin typeface="+mn-lt"/>
+                        </a:rPr>
+                        <a:t> problem</a:t>
+                      </a:r>
+                      <a:endParaRPr sz="1030" dirty="0">
+                        <a:solidFill>
+                          <a:srgbClr val="1A1F2B"/>
+                        </a:solidFill>
+                        <a:latin typeface="Calibri"/>
+                      </a:endParaRPr>
                     </a:p>
                   </a:txBody>
                   <a:tcPr marT="38100" marB="38100" anchor="ctr">
@@ -15367,7 +16717,7 @@
                           </a:solidFill>
                           <a:latin typeface="Calibri"/>
                         </a:rPr>
-                        <a:t>7B model's VRAM footprint too large for the available GPUs</a:t>
+                        <a:t>codegen-350M-multi threw index-out-of-bounds errors; CUDA:1 tensors held garbage values — hooks, rope_scaling and token-limit fixes all failed</a:t>
                       </a:r>
                     </a:p>
                   </a:txBody>
@@ -15388,13 +16738,13 @@
                         </a:lnSpc>
                       </a:pPr>
                       <a:r>
-                        <a:rPr sz="1030">
+                        <a:rPr sz="1030" dirty="0">
                           <a:solidFill>
                             <a:srgbClr val="1A1F2B"/>
                           </a:solidFill>
                           <a:latin typeface="Calibri"/>
                         </a:rPr>
-                        <a:t>4-bit quantization (BitsAndBytes) cut usage from ~14 GB to ~4 GB</a:t>
+                        <a:t>Pinned to a single GPU (CUDA_VISIBLE_DEVICES) with CUDA_LAUNCH_BLOCKING / TORCH_USE_CUDA_DSA for debugging</a:t>
                       </a:r>
                     </a:p>
                   </a:txBody>
@@ -15422,13 +16772,13 @@
                         </a:lnSpc>
                       </a:pPr>
                       <a:r>
-                        <a:rPr sz="1030">
+                        <a:rPr sz="1030" dirty="0">
                           <a:solidFill>
                             <a:srgbClr val="1A1F2B"/>
                           </a:solidFill>
                           <a:latin typeface="Calibri"/>
                         </a:rPr>
-                        <a:t>Fine-tuning still hit a hard OOM ceiling — only ~33 records could be processed</a:t>
+                        <a:t>7B model's VRAM footprint too large for the available GPUs</a:t>
                       </a:r>
                     </a:p>
                   </a:txBody>
@@ -15449,13 +16799,31 @@
                         </a:lnSpc>
                       </a:pPr>
                       <a:r>
-                        <a:rPr sz="1030">
+                        <a:rPr sz="1030" dirty="0">
                           <a:solidFill>
                             <a:srgbClr val="1A1F2B"/>
                           </a:solidFill>
                           <a:latin typeface="Calibri"/>
                         </a:rPr>
-                        <a:t>Cache-clearing + garbage collection helped marginally; no complete fix found</a:t>
+                        <a:t>4-bit quantization (</a:t>
+                      </a:r>
+                      <a:r>
+                        <a:rPr sz="1030" dirty="0" err="1">
+                          <a:solidFill>
+                            <a:srgbClr val="1A1F2B"/>
+                          </a:solidFill>
+                          <a:latin typeface="Calibri"/>
+                        </a:rPr>
+                        <a:t>BitsAndBytes</a:t>
+                      </a:r>
+                      <a:r>
+                        <a:rPr sz="1030" dirty="0">
+                          <a:solidFill>
+                            <a:srgbClr val="1A1F2B"/>
+                          </a:solidFill>
+                          <a:latin typeface="Calibri"/>
+                        </a:rPr>
+                        <a:t>) cut usage from ~14 GB to ~4 GB</a:t>
                       </a:r>
                     </a:p>
                   </a:txBody>
@@ -15571,13 +16939,49 @@
                         </a:lnSpc>
                       </a:pPr>
                       <a:r>
-                        <a:rPr sz="1030">
+                        <a:rPr sz="1030" dirty="0">
                           <a:solidFill>
                             <a:srgbClr val="1A1F2B"/>
                           </a:solidFill>
                           <a:latin typeface="Calibri"/>
                         </a:rPr>
-                        <a:t>Used Qwen as an LLM-judge scoring compiles / logic_correct / edge_cases / verdict, plus a 0–1 score</a:t>
+                        <a:t>Used Qwen as an LLM-judge scoring compiles / </a:t>
+                      </a:r>
+                      <a:r>
+                        <a:rPr sz="1030" dirty="0" err="1">
+                          <a:solidFill>
+                            <a:srgbClr val="1A1F2B"/>
+                          </a:solidFill>
+                          <a:latin typeface="Calibri"/>
+                        </a:rPr>
+                        <a:t>logic_correct</a:t>
+                      </a:r>
+                      <a:r>
+                        <a:rPr sz="1030" dirty="0">
+                          <a:solidFill>
+                            <a:srgbClr val="1A1F2B"/>
+                          </a:solidFill>
+                          <a:latin typeface="Calibri"/>
+                        </a:rPr>
+                        <a:t> / </a:t>
+                      </a:r>
+                      <a:r>
+                        <a:rPr sz="1030" dirty="0" err="1">
+                          <a:solidFill>
+                            <a:srgbClr val="1A1F2B"/>
+                          </a:solidFill>
+                          <a:latin typeface="Calibri"/>
+                        </a:rPr>
+                        <a:t>edge_cases</a:t>
+                      </a:r>
+                      <a:r>
+                        <a:rPr sz="1030" dirty="0">
+                          <a:solidFill>
+                            <a:srgbClr val="1A1F2B"/>
+                          </a:solidFill>
+                          <a:latin typeface="Calibri"/>
+                        </a:rPr>
+                        <a:t> / verdict, plus a 0–1 score</a:t>
                       </a:r>
                     </a:p>
                   </a:txBody>

</xml_diff>